<commit_message>
Add desktop GUI (banking_gui.py, pure Python Tkinter)
- Operations console: overview with work queue, 20 operation forms,
  14 guided rule checks, customers with role timelines and time machine,
  accounts, transactions, cards, cases, staff, products and branches,
  books and audit, class model read from the code, scenario log
- Every button calls one Bank operation; refusals show the model's error
- GUI classes use inheritance: Page -> MasterDetailPage -> screens
- Docs: README section, report section 11 with screenshots, viva slide,
  checklist and viva notes

Co-Authored-By: Claude Opus 5.5 <noreply@anthropic.com>
Claude-Session: https://claude.ai/code/session_01SahYJB3mwF36eBHRbWfj6o
</commit_message>
<xml_diff>
--- a/docs/Viva_Presentation.pptx
+++ b/docs/Viva_Presentation.pptx
@@ -17,9 +17,10 @@
     <p:sldId id="265" r:id="rId11"/>
     <p:sldId id="266" r:id="rId12"/>
     <p:sldId id="267" r:id="rId13"/>
+    <p:sldId id="268" r:id="rId14"/>
   </p:sldIdLst>
   <p:notesMasterIdLst>
-    <p:notesMasterId r:id="rId14"/>
+    <p:notesMasterId r:id="rId15"/>
   </p:notesMasterIdLst>
   <p:sldSz cx="9144000" cy="5143500"/>
   <p:notesSz cx="5143500" cy="9144000"/>
@@ -689,7 +690,7 @@
           <a:p>
             <a:r>
               <a:rPr lang="en-US" dirty="0"/>
-              <a:t>Full table in docs/Code_Review.md. Every fix is protected by a test, so it cannot silently come back.</a:t>
+              <a:t>Run Operations &gt; Guided rule checks in order. Then Customers: Ayesha's roles as ribbons, and the time machine on 11 April 2026. The GUI contains no business rules: refusals come from the model and name its error class.</a:t>
             </a:r>
             <a:endParaRPr lang="en-US" dirty="0"/>
           </a:p>
@@ -777,7 +778,7 @@
           <a:p>
             <a:r>
               <a:rPr lang="en-US" dirty="0"/>
-              <a:t>The Arrangement level is where the design pays off for new business models: an Ijarah or Murabaha contract is a new kind of arrangement, not a change to existing classes.</a:t>
+              <a:t>Full table in docs/Code_Review.md. Every fix is protected by a test, so it cannot silently come back.</a:t>
             </a:r>
             <a:endParaRPr lang="en-US" dirty="0"/>
           </a:p>
@@ -801,6 +802,94 @@
             <a:fld id="{F7021451-1387-4CA6-816F-3879F97B5CBC}" type="slidenum">
               <a:rPr lang="en-US"/>
               <a:t>12</a:t>
+            </a:fld>
+            <a:endParaRPr lang="en-US"/>
+          </a:p>
+        </p:txBody>
+      </p:sp>
+    </p:spTree>
+    <p:extLst>
+      <p:ext uri="{BB962C8B-B14F-4D97-AF65-F5344CB8AC3E}">
+        <p14:creationId xmlns:p14="http://schemas.microsoft.com/office/powerpoint/2010/main" val="1024086991"/>
+      </p:ext>
+    </p:extLst>
+  </p:cSld>
+  <p:clrMapOvr>
+    <a:masterClrMapping/>
+  </p:clrMapOvr>
+</p:notes>
+</file>
+
+<file path=ppt/notesSlides/notesSlide13.xml><?xml version="1.0" encoding="utf-8"?>
+<p:notes xmlns:a="http://schemas.openxmlformats.org/drawingml/2006/main" xmlns:r="http://schemas.openxmlformats.org/officeDocument/2006/relationships" xmlns:p="http://schemas.openxmlformats.org/presentationml/2006/main">
+  <p:cSld>
+    <p:spTree>
+      <p:nvGrpSpPr>
+        <p:cNvPr id="1" name=""/>
+        <p:cNvGrpSpPr/>
+        <p:nvPr/>
+      </p:nvGrpSpPr>
+      <p:grpSpPr>
+        <a:xfrm>
+          <a:off x="0" y="0"/>
+          <a:ext cx="0" cy="0"/>
+          <a:chOff x="0" y="0"/>
+          <a:chExt cx="0" cy="0"/>
+        </a:xfrm>
+      </p:grpSpPr>
+      <p:sp>
+        <p:nvSpPr>
+          <p:cNvPr id="2" name="Slide Image Placeholder 1"/>
+          <p:cNvSpPr>
+            <a:spLocks noGrp="1" noRot="1" noChangeAspect="1"/>
+          </p:cNvSpPr>
+          <p:nvPr>
+            <p:ph type="sldImg"/>
+          </p:nvPr>
+        </p:nvSpPr>
+        <p:spPr/>
+      </p:sp>
+      <p:sp>
+        <p:nvSpPr>
+          <p:cNvPr id="3" name="Notes Placeholder 2"/>
+          <p:cNvSpPr>
+            <a:spLocks noGrp="1"/>
+          </p:cNvSpPr>
+          <p:nvPr>
+            <p:ph type="body" idx="1"/>
+          </p:nvPr>
+        </p:nvSpPr>
+        <p:spPr/>
+        <p:txBody>
+          <a:bodyPr/>
+          <a:lstStyle/>
+          <a:p>
+            <a:r>
+              <a:rPr lang="en-US" dirty="0"/>
+              <a:t>The Arrangement level is where the design pays off for new business models: an Ijarah or Murabaha contract is a new kind of arrangement, not a change to existing classes.</a:t>
+            </a:r>
+            <a:endParaRPr lang="en-US" dirty="0"/>
+          </a:p>
+        </p:txBody>
+      </p:sp>
+      <p:sp>
+        <p:nvSpPr>
+          <p:cNvPr id="4" name="Slide Number Placeholder 3"/>
+          <p:cNvSpPr>
+            <a:spLocks noGrp="1"/>
+          </p:cNvSpPr>
+          <p:nvPr>
+            <p:ph type="sldNum" sz="quarter" idx="10"/>
+          </p:nvPr>
+        </p:nvSpPr>
+        <p:spPr/>
+        <p:txBody>
+          <a:bodyPr/>
+          <a:lstStyle/>
+          <a:p>
+            <a:fld id="{F7021451-1387-4CA6-816F-3879F97B5CBC}" type="slidenum">
+              <a:rPr lang="en-US"/>
+              <a:t>13</a:t>
             </a:fld>
             <a:endParaRPr lang="en-US"/>
           </a:p>
@@ -2845,7 +2934,7 @@
               <a:buNone/>
             </a:pPr>
             <a:r>
-              <a:rPr lang="en-US" sz="2200" b="1" dirty="0">
+              <a:rPr lang="en-US" sz="2800" b="1" dirty="0">
                 <a:solidFill>
                   <a:srgbClr val="0B4F4A"/>
                 </a:solidFill>
@@ -2853,127 +2942,112 @@
                 <a:ea typeface="Cambria" pitchFamily="34" charset="-122"/>
                 <a:cs typeface="Cambria" pitchFamily="34" charset="-120"/>
               </a:rPr>
-              <a:t>Code review: 20 defects fixed, each with a test</a:t>
-            </a:r>
-            <a:endParaRPr lang="en-US" sz="2200" dirty="0"/>
-          </a:p>
-        </p:txBody>
-      </p:sp>
-      <p:sp>
-        <p:nvSpPr>
-          <p:cNvPr id="3" name="Shape 1"/>
+              <a:t>Live demo: the desktop console</a:t>
+            </a:r>
+            <a:endParaRPr lang="en-US" sz="2800" dirty="0"/>
+          </a:p>
+        </p:txBody>
+      </p:sp>
+      <p:sp>
+        <p:nvSpPr>
+          <p:cNvPr id="3" name="Text 1"/>
+          <p:cNvSpPr txBox="1"/>
+          <p:nvPr/>
+        </p:nvSpPr>
+        <p:spPr>
+          <a:xfrm>
+            <a:off x="457200" y="804672"/>
+            <a:ext cx="8229600" cy="320040"/>
+          </a:xfrm>
+          <a:prstGeom prst="rect">
+            <a:avLst/>
+          </a:prstGeom>
+          <a:noFill/>
+          <a:ln/>
+        </p:spPr>
+        <p:txBody>
+          <a:bodyPr wrap="square" lIns="0" tIns="0" rIns="0" bIns="0" rtlCol="0" anchor="ctr"/>
+          <a:lstStyle/>
+          <a:p>
+            <a:pPr indent="0" marL="0">
+              <a:buNone/>
+            </a:pPr>
+            <a:r>
+              <a:rPr lang="en-US" sz="1200" i="1" dirty="0">
+                <a:solidFill>
+                  <a:srgbClr val="5B6B69"/>
+                </a:solidFill>
+                <a:latin typeface="Calibri" pitchFamily="34" charset="0"/>
+                <a:ea typeface="Calibri" pitchFamily="34" charset="-122"/>
+                <a:cs typeface="Calibri" pitchFamily="34" charset="-120"/>
+              </a:rPr>
+              <a:t>banking_gui.py - pure Python (Tkinter); every button calls one Bank operation</a:t>
+            </a:r>
+            <a:endParaRPr lang="en-US" sz="1200" dirty="0"/>
+          </a:p>
+        </p:txBody>
+      </p:sp>
+      <p:sp>
+        <p:nvSpPr>
+          <p:cNvPr id="4" name="Shape 2"/>
           <p:cNvSpPr/>
           <p:nvPr/>
         </p:nvSpPr>
         <p:spPr>
           <a:xfrm>
-            <a:off x="457200" y="1097280"/>
-            <a:ext cx="2651760" cy="3566160"/>
+            <a:off x="457200" y="1188720"/>
+            <a:ext cx="5577840" cy="3611880"/>
           </a:xfrm>
           <a:prstGeom prst="roundRect">
             <a:avLst>
-              <a:gd name="adj" fmla="val 2759"/>
+              <a:gd name="adj" fmla="val 2025"/>
             </a:avLst>
           </a:prstGeom>
           <a:solidFill>
-            <a:srgbClr val="0B4F4A"/>
+            <a:srgbClr val="F4F8F7"/>
           </a:solidFill>
           <a:ln w="12700">
             <a:solidFill>
-              <a:srgbClr val="0B4F4A"/>
+              <a:srgbClr val="F4F8F7"/>
             </a:solidFill>
             <a:prstDash val="solid"/>
           </a:ln>
         </p:spPr>
       </p:sp>
-      <p:sp>
-        <p:nvSpPr>
-          <p:cNvPr id="4" name="Text 2"/>
-          <p:cNvSpPr txBox="1"/>
-          <p:nvPr/>
-        </p:nvSpPr>
-        <p:spPr>
-          <a:xfrm>
-            <a:off x="457200" y="1463040"/>
-            <a:ext cx="2651760" cy="1097280"/>
-          </a:xfrm>
-          <a:prstGeom prst="rect">
-            <a:avLst/>
-          </a:prstGeom>
-          <a:noFill/>
-          <a:ln/>
-        </p:spPr>
-        <p:txBody>
-          <a:bodyPr wrap="square" lIns="0" tIns="0" rIns="0" bIns="0" rtlCol="0" anchor="ctr"/>
-          <a:lstStyle/>
-          <a:p>
-            <a:pPr algn="ctr" indent="0" marL="0">
-              <a:buNone/>
-            </a:pPr>
-            <a:r>
-              <a:rPr lang="en-US" sz="6000" b="1" dirty="0">
-                <a:solidFill>
-                  <a:srgbClr val="FFFFFF"/>
-                </a:solidFill>
-                <a:latin typeface="Cambria" pitchFamily="34" charset="0"/>
-                <a:ea typeface="Cambria" pitchFamily="34" charset="-122"/>
-                <a:cs typeface="Cambria" pitchFamily="34" charset="-120"/>
-              </a:rPr>
-              <a:t>20</a:t>
-            </a:r>
-            <a:endParaRPr lang="en-US" sz="6000" dirty="0"/>
-          </a:p>
-        </p:txBody>
-      </p:sp>
-      <p:sp>
-        <p:nvSpPr>
-          <p:cNvPr id="5" name="Text 3"/>
-          <p:cNvSpPr txBox="1"/>
-          <p:nvPr/>
-        </p:nvSpPr>
-        <p:spPr>
-          <a:xfrm>
-            <a:off x="685800" y="2651760"/>
-            <a:ext cx="2194560" cy="1097280"/>
-          </a:xfrm>
-          <a:prstGeom prst="rect">
-            <a:avLst/>
-          </a:prstGeom>
-          <a:noFill/>
-          <a:ln/>
-        </p:spPr>
-        <p:txBody>
-          <a:bodyPr wrap="square" lIns="0" tIns="0" rIns="0" bIns="0" rtlCol="0" anchor="ctr"/>
-          <a:lstStyle/>
-          <a:p>
-            <a:pPr algn="ctr" indent="0" marL="0">
-              <a:buNone/>
-            </a:pPr>
-            <a:r>
-              <a:rPr lang="en-US" sz="1400" dirty="0">
-                <a:solidFill>
-                  <a:srgbClr val="CFE3DF"/>
-                </a:solidFill>
-                <a:latin typeface="Calibri" pitchFamily="34" charset="0"/>
-                <a:ea typeface="Calibri" pitchFamily="34" charset="-122"/>
-                <a:cs typeface="Calibri" pitchFamily="34" charset="-120"/>
-              </a:rPr>
-              <a:t>defects found and fixed, each with a regression test</a:t>
-            </a:r>
-            <a:endParaRPr lang="en-US" sz="1400" dirty="0"/>
-          </a:p>
-        </p:txBody>
-      </p:sp>
-      <p:sp>
-        <p:nvSpPr>
-          <p:cNvPr id="6" name="Text 4"/>
-          <p:cNvSpPr txBox="1"/>
-          <p:nvPr/>
-        </p:nvSpPr>
-        <p:spPr>
-          <a:xfrm>
-            <a:off x="3474720" y="1143000"/>
-            <a:ext cx="5212080" cy="3566160"/>
+      <p:pic>
+        <p:nvPicPr>
+          <p:cNvPr id="5" name="Image 0" descr="/home/user/commercial-banking/docs/screenshots/gui_01_overview.png">    </p:cNvPr>
+          <p:cNvPicPr>
+            <a:picLocks noChangeAspect="1"/>
+          </p:cNvPicPr>
+          <p:nvPr/>
+        </p:nvPicPr>
+        <p:blipFill>
+          <a:blip r:embed="rId1"/>
+          <a:stretch>
+            <a:fillRect/>
+          </a:stretch>
+        </p:blipFill>
+        <p:spPr>
+          <a:xfrm>
+            <a:off x="548640" y="1280160"/>
+            <a:ext cx="5394960" cy="3291840"/>
+          </a:xfrm>
+          <a:prstGeom prst="rect">
+            <a:avLst/>
+          </a:prstGeom>
+        </p:spPr>
+      </p:pic>
+      <p:sp>
+        <p:nvSpPr>
+          <p:cNvPr id="6" name="Text 3"/>
+          <p:cNvSpPr txBox="1"/>
+          <p:nvPr/>
+        </p:nvSpPr>
+        <p:spPr>
+          <a:xfrm>
+            <a:off x="6263640" y="1234440"/>
+            <a:ext cx="2468880" cy="3566160"/>
           </a:xfrm>
           <a:prstGeom prst="rect">
             <a:avLst/>
@@ -2993,7 +3067,7 @@
               <a:buChar char="•"/>
             </a:pPr>
             <a:r>
-              <a:rPr lang="en-US" sz="1350" dirty="0">
+              <a:rPr lang="en-US" sz="1200" dirty="0">
                 <a:solidFill>
                   <a:srgbClr val="1D2B2A"/>
                 </a:solidFill>
@@ -3001,9 +3075,9 @@
                 <a:ea typeface="Calibri" pitchFamily="34" charset="-122"/>
                 <a:cs typeface="Calibri" pitchFamily="34" charset="-120"/>
               </a:rPr>
-              <a:t>A refused loan overpayment still marked installments as paid</a:t>
-            </a:r>
-            <a:endParaRPr lang="en-US" sz="1350" dirty="0"/>
+              <a:t>Guided rule checks: 14 real operations, each showing the model's own refusal</a:t>
+            </a:r>
+            <a:endParaRPr lang="en-US" sz="1200" dirty="0"/>
           </a:p>
           <a:p>
             <a:pPr marL="342900" indent="-342900">
@@ -3014,7 +3088,7 @@
               <a:buChar char="•"/>
             </a:pPr>
             <a:r>
-              <a:rPr lang="en-US" sz="1350" dirty="0">
+              <a:rPr lang="en-US" sz="1200" dirty="0">
                 <a:solidFill>
                   <a:srgbClr val="1D2B2A"/>
                 </a:solidFill>
@@ -3022,9 +3096,9 @@
                 <a:ea typeface="Calibri" pitchFamily="34" charset="-122"/>
                 <a:cs typeface="Calibri" pitchFamily="34" charset="-120"/>
               </a:rPr>
-              <a:t>Resolving a dispute twice refunded the customer twice</a:t>
-            </a:r>
-            <a:endParaRPr lang="en-US" sz="1350" dirty="0"/>
+              <a:t>Customer timeline and time machine for any past date</a:t>
+            </a:r>
+            <a:endParaRPr lang="en-US" sz="1200" dirty="0"/>
           </a:p>
           <a:p>
             <a:pPr marL="342900" indent="-342900">
@@ -3035,7 +3109,7 @@
               <a:buChar char="•"/>
             </a:pPr>
             <a:r>
-              <a:rPr lang="en-US" sz="1350" dirty="0">
+              <a:rPr lang="en-US" sz="1200" dirty="0">
                 <a:solidFill>
                   <a:srgbClr val="1D2B2A"/>
                 </a:solidFill>
@@ -3043,9 +3117,9 @@
                 <a:ea typeface="Calibri" pitchFamily="34" charset="-122"/>
                 <a:cs typeface="Calibri" pitchFamily="34" charset="-120"/>
               </a:rPr>
-              <a:t>Recording an ACTIVE card as found destroyed it</a:t>
-            </a:r>
-            <a:endParaRPr lang="en-US" sz="1350" dirty="0"/>
+              <a:t>Card chains, cases, audit log and a zero trial balance</a:t>
+            </a:r>
+            <a:endParaRPr lang="en-US" sz="1200" dirty="0"/>
           </a:p>
           <a:p>
             <a:pPr marL="342900" indent="-342900">
@@ -3056,7 +3130,7 @@
               <a:buChar char="•"/>
             </a:pPr>
             <a:r>
-              <a:rPr lang="en-US" sz="1350" dirty="0">
+              <a:rPr lang="en-US" sz="1200" dirty="0">
                 <a:solidFill>
                   <a:srgbClr val="1D2B2A"/>
                 </a:solidFill>
@@ -3064,72 +3138,9 @@
                 <a:ea typeface="Calibri" pitchFamily="34" charset="-122"/>
                 <a:cs typeface="Calibri" pitchFamily="34" charset="-120"/>
               </a:rPr>
-              <a:t>Replacement cards blocked once the product was withdrawn</a:t>
-            </a:r>
-            <a:endParaRPr lang="en-US" sz="1350" dirty="0"/>
-          </a:p>
-          <a:p>
-            <a:pPr marL="342900" indent="-342900">
-              <a:spcAft>
-                <a:spcPts val="600"/>
-              </a:spcAft>
-              <a:buSzPct val="100000"/>
-              <a:buChar char="•"/>
-            </a:pPr>
-            <a:r>
-              <a:rPr lang="en-US" sz="1350" dirty="0">
-                <a:solidFill>
-                  <a:srgbClr val="1D2B2A"/>
-                </a:solidFill>
-                <a:latin typeface="Calibri" pitchFamily="34" charset="0"/>
-                <a:ea typeface="Calibri" pitchFamily="34" charset="-122"/>
-                <a:cs typeface="Calibri" pitchFamily="34" charset="-120"/>
-              </a:rPr>
-              <a:t>Bank fees used up customers' savings withdrawals</a:t>
-            </a:r>
-            <a:endParaRPr lang="en-US" sz="1350" dirty="0"/>
-          </a:p>
-          <a:p>
-            <a:pPr marL="342900" indent="-342900">
-              <a:spcAft>
-                <a:spcPts val="600"/>
-              </a:spcAft>
-              <a:buSzPct val="100000"/>
-              <a:buChar char="•"/>
-            </a:pPr>
-            <a:r>
-              <a:rPr lang="en-US" sz="1350" dirty="0">
-                <a:solidFill>
-                  <a:srgbClr val="1D2B2A"/>
-                </a:solidFill>
-                <a:latin typeface="Calibri" pitchFamily="34" charset="0"/>
-                <a:ea typeface="Calibri" pitchFamily="34" charset="-122"/>
-                <a:cs typeface="Calibri" pitchFamily="34" charset="-120"/>
-              </a:rPr>
-              <a:t>Account closure ignored holds and pending payments</a:t>
-            </a:r>
-            <a:endParaRPr lang="en-US" sz="1350" dirty="0"/>
-          </a:p>
-          <a:p>
-            <a:pPr marL="342900" indent="-342900">
-              <a:spcAft>
-                <a:spcPts val="600"/>
-              </a:spcAft>
-              <a:buSzPct val="100000"/>
-              <a:buChar char="•"/>
-            </a:pPr>
-            <a:r>
-              <a:rPr lang="en-US" sz="1350" dirty="0">
-                <a:solidFill>
-                  <a:srgbClr val="1D2B2A"/>
-                </a:solidFill>
-                <a:latin typeface="Calibri" pitchFamily="34" charset="0"/>
-                <a:ea typeface="Calibri" pitchFamily="34" charset="-122"/>
-                <a:cs typeface="Calibri" pitchFamily="34" charset="-120"/>
-              </a:rPr>
-              <a:t>No delegated limit on credit approvals</a:t>
-            </a:r>
-            <a:endParaRPr lang="en-US" sz="1350" dirty="0"/>
+              <a:t>GUI classes inherit too: Page -&gt; MasterDetailPage -&gt; CustomersPage</a:t>
+            </a:r>
+            <a:endParaRPr lang="en-US" sz="1200" dirty="0"/>
           </a:p>
         </p:txBody>
       </p:sp>
@@ -3144,6 +3155,353 @@
 <file path=ppt/slides/slide12.xml><?xml version="1.0" encoding="utf-8"?>
 <p:sld xmlns:a="http://schemas.openxmlformats.org/drawingml/2006/main" xmlns:r="http://schemas.openxmlformats.org/officeDocument/2006/relationships" xmlns:p="http://schemas.openxmlformats.org/presentationml/2006/main">
   <p:cSld name="Slide 12">
+    <p:bg>
+      <p:bgPr>
+        <a:solidFill>
+          <a:srgbClr val="FFFFFF"/>
+        </a:solidFill>
+      </p:bgPr>
+    </p:bg>
+    <p:spTree>
+      <p:nvGrpSpPr>
+        <p:cNvPr id="1" name=""/>
+        <p:cNvGrpSpPr/>
+        <p:nvPr/>
+      </p:nvGrpSpPr>
+      <p:grpSpPr>
+        <a:xfrm>
+          <a:off x="0" y="0"/>
+          <a:ext cx="0" cy="0"/>
+          <a:chOff x="0" y="0"/>
+          <a:chExt cx="0" cy="0"/>
+        </a:xfrm>
+      </p:grpSpPr>
+      <p:sp>
+        <p:nvSpPr>
+          <p:cNvPr id="2" name="Text 0"/>
+          <p:cNvSpPr txBox="1"/>
+          <p:nvPr/>
+        </p:nvSpPr>
+        <p:spPr>
+          <a:xfrm>
+            <a:off x="457200" y="274320"/>
+            <a:ext cx="8229600" cy="548640"/>
+          </a:xfrm>
+          <a:prstGeom prst="rect">
+            <a:avLst/>
+          </a:prstGeom>
+          <a:noFill/>
+          <a:ln/>
+        </p:spPr>
+        <p:txBody>
+          <a:bodyPr wrap="square" lIns="0" tIns="0" rIns="0" bIns="0" rtlCol="0" anchor="ctr">
+            <a:normAutofit/>
+          </a:bodyPr>
+          <a:lstStyle/>
+          <a:p>
+            <a:pPr indent="0" marL="0">
+              <a:buNone/>
+            </a:pPr>
+            <a:r>
+              <a:rPr lang="en-US" sz="2200" b="1" dirty="0">
+                <a:solidFill>
+                  <a:srgbClr val="0B4F4A"/>
+                </a:solidFill>
+                <a:latin typeface="Cambria" pitchFamily="34" charset="0"/>
+                <a:ea typeface="Cambria" pitchFamily="34" charset="-122"/>
+                <a:cs typeface="Cambria" pitchFamily="34" charset="-120"/>
+              </a:rPr>
+              <a:t>Code review: 20 defects fixed, each with a test</a:t>
+            </a:r>
+            <a:endParaRPr lang="en-US" sz="2200" dirty="0"/>
+          </a:p>
+        </p:txBody>
+      </p:sp>
+      <p:sp>
+        <p:nvSpPr>
+          <p:cNvPr id="3" name="Shape 1"/>
+          <p:cNvSpPr/>
+          <p:nvPr/>
+        </p:nvSpPr>
+        <p:spPr>
+          <a:xfrm>
+            <a:off x="457200" y="1097280"/>
+            <a:ext cx="2651760" cy="3566160"/>
+          </a:xfrm>
+          <a:prstGeom prst="roundRect">
+            <a:avLst>
+              <a:gd name="adj" fmla="val 2759"/>
+            </a:avLst>
+          </a:prstGeom>
+          <a:solidFill>
+            <a:srgbClr val="0B4F4A"/>
+          </a:solidFill>
+          <a:ln w="12700">
+            <a:solidFill>
+              <a:srgbClr val="0B4F4A"/>
+            </a:solidFill>
+            <a:prstDash val="solid"/>
+          </a:ln>
+        </p:spPr>
+      </p:sp>
+      <p:sp>
+        <p:nvSpPr>
+          <p:cNvPr id="4" name="Text 2"/>
+          <p:cNvSpPr txBox="1"/>
+          <p:nvPr/>
+        </p:nvSpPr>
+        <p:spPr>
+          <a:xfrm>
+            <a:off x="457200" y="1463040"/>
+            <a:ext cx="2651760" cy="1097280"/>
+          </a:xfrm>
+          <a:prstGeom prst="rect">
+            <a:avLst/>
+          </a:prstGeom>
+          <a:noFill/>
+          <a:ln/>
+        </p:spPr>
+        <p:txBody>
+          <a:bodyPr wrap="square" lIns="0" tIns="0" rIns="0" bIns="0" rtlCol="0" anchor="ctr"/>
+          <a:lstStyle/>
+          <a:p>
+            <a:pPr algn="ctr" indent="0" marL="0">
+              <a:buNone/>
+            </a:pPr>
+            <a:r>
+              <a:rPr lang="en-US" sz="6000" b="1" dirty="0">
+                <a:solidFill>
+                  <a:srgbClr val="FFFFFF"/>
+                </a:solidFill>
+                <a:latin typeface="Cambria" pitchFamily="34" charset="0"/>
+                <a:ea typeface="Cambria" pitchFamily="34" charset="-122"/>
+                <a:cs typeface="Cambria" pitchFamily="34" charset="-120"/>
+              </a:rPr>
+              <a:t>20</a:t>
+            </a:r>
+            <a:endParaRPr lang="en-US" sz="6000" dirty="0"/>
+          </a:p>
+        </p:txBody>
+      </p:sp>
+      <p:sp>
+        <p:nvSpPr>
+          <p:cNvPr id="5" name="Text 3"/>
+          <p:cNvSpPr txBox="1"/>
+          <p:nvPr/>
+        </p:nvSpPr>
+        <p:spPr>
+          <a:xfrm>
+            <a:off x="685800" y="2651760"/>
+            <a:ext cx="2194560" cy="1097280"/>
+          </a:xfrm>
+          <a:prstGeom prst="rect">
+            <a:avLst/>
+          </a:prstGeom>
+          <a:noFill/>
+          <a:ln/>
+        </p:spPr>
+        <p:txBody>
+          <a:bodyPr wrap="square" lIns="0" tIns="0" rIns="0" bIns="0" rtlCol="0" anchor="ctr"/>
+          <a:lstStyle/>
+          <a:p>
+            <a:pPr algn="ctr" indent="0" marL="0">
+              <a:buNone/>
+            </a:pPr>
+            <a:r>
+              <a:rPr lang="en-US" sz="1400" dirty="0">
+                <a:solidFill>
+                  <a:srgbClr val="CFE3DF"/>
+                </a:solidFill>
+                <a:latin typeface="Calibri" pitchFamily="34" charset="0"/>
+                <a:ea typeface="Calibri" pitchFamily="34" charset="-122"/>
+                <a:cs typeface="Calibri" pitchFamily="34" charset="-120"/>
+              </a:rPr>
+              <a:t>defects found and fixed, each with a regression test</a:t>
+            </a:r>
+            <a:endParaRPr lang="en-US" sz="1400" dirty="0"/>
+          </a:p>
+        </p:txBody>
+      </p:sp>
+      <p:sp>
+        <p:nvSpPr>
+          <p:cNvPr id="6" name="Text 4"/>
+          <p:cNvSpPr txBox="1"/>
+          <p:nvPr/>
+        </p:nvSpPr>
+        <p:spPr>
+          <a:xfrm>
+            <a:off x="3474720" y="1143000"/>
+            <a:ext cx="5212080" cy="3566160"/>
+          </a:xfrm>
+          <a:prstGeom prst="rect">
+            <a:avLst/>
+          </a:prstGeom>
+          <a:noFill/>
+          <a:ln/>
+        </p:spPr>
+        <p:txBody>
+          <a:bodyPr wrap="square" lIns="635" tIns="635" rIns="635" bIns="635" rtlCol="0" anchor="t"/>
+          <a:lstStyle/>
+          <a:p>
+            <a:pPr marL="342900" indent="-342900">
+              <a:spcAft>
+                <a:spcPts val="600"/>
+              </a:spcAft>
+              <a:buSzPct val="100000"/>
+              <a:buChar char="•"/>
+            </a:pPr>
+            <a:r>
+              <a:rPr lang="en-US" sz="1350" dirty="0">
+                <a:solidFill>
+                  <a:srgbClr val="1D2B2A"/>
+                </a:solidFill>
+                <a:latin typeface="Calibri" pitchFamily="34" charset="0"/>
+                <a:ea typeface="Calibri" pitchFamily="34" charset="-122"/>
+                <a:cs typeface="Calibri" pitchFamily="34" charset="-120"/>
+              </a:rPr>
+              <a:t>A refused loan overpayment still marked installments as paid</a:t>
+            </a:r>
+            <a:endParaRPr lang="en-US" sz="1350" dirty="0"/>
+          </a:p>
+          <a:p>
+            <a:pPr marL="342900" indent="-342900">
+              <a:spcAft>
+                <a:spcPts val="600"/>
+              </a:spcAft>
+              <a:buSzPct val="100000"/>
+              <a:buChar char="•"/>
+            </a:pPr>
+            <a:r>
+              <a:rPr lang="en-US" sz="1350" dirty="0">
+                <a:solidFill>
+                  <a:srgbClr val="1D2B2A"/>
+                </a:solidFill>
+                <a:latin typeface="Calibri" pitchFamily="34" charset="0"/>
+                <a:ea typeface="Calibri" pitchFamily="34" charset="-122"/>
+                <a:cs typeface="Calibri" pitchFamily="34" charset="-120"/>
+              </a:rPr>
+              <a:t>Resolving a dispute twice refunded the customer twice</a:t>
+            </a:r>
+            <a:endParaRPr lang="en-US" sz="1350" dirty="0"/>
+          </a:p>
+          <a:p>
+            <a:pPr marL="342900" indent="-342900">
+              <a:spcAft>
+                <a:spcPts val="600"/>
+              </a:spcAft>
+              <a:buSzPct val="100000"/>
+              <a:buChar char="•"/>
+            </a:pPr>
+            <a:r>
+              <a:rPr lang="en-US" sz="1350" dirty="0">
+                <a:solidFill>
+                  <a:srgbClr val="1D2B2A"/>
+                </a:solidFill>
+                <a:latin typeface="Calibri" pitchFamily="34" charset="0"/>
+                <a:ea typeface="Calibri" pitchFamily="34" charset="-122"/>
+                <a:cs typeface="Calibri" pitchFamily="34" charset="-120"/>
+              </a:rPr>
+              <a:t>Recording an ACTIVE card as found destroyed it</a:t>
+            </a:r>
+            <a:endParaRPr lang="en-US" sz="1350" dirty="0"/>
+          </a:p>
+          <a:p>
+            <a:pPr marL="342900" indent="-342900">
+              <a:spcAft>
+                <a:spcPts val="600"/>
+              </a:spcAft>
+              <a:buSzPct val="100000"/>
+              <a:buChar char="•"/>
+            </a:pPr>
+            <a:r>
+              <a:rPr lang="en-US" sz="1350" dirty="0">
+                <a:solidFill>
+                  <a:srgbClr val="1D2B2A"/>
+                </a:solidFill>
+                <a:latin typeface="Calibri" pitchFamily="34" charset="0"/>
+                <a:ea typeface="Calibri" pitchFamily="34" charset="-122"/>
+                <a:cs typeface="Calibri" pitchFamily="34" charset="-120"/>
+              </a:rPr>
+              <a:t>Replacement cards blocked once the product was withdrawn</a:t>
+            </a:r>
+            <a:endParaRPr lang="en-US" sz="1350" dirty="0"/>
+          </a:p>
+          <a:p>
+            <a:pPr marL="342900" indent="-342900">
+              <a:spcAft>
+                <a:spcPts val="600"/>
+              </a:spcAft>
+              <a:buSzPct val="100000"/>
+              <a:buChar char="•"/>
+            </a:pPr>
+            <a:r>
+              <a:rPr lang="en-US" sz="1350" dirty="0">
+                <a:solidFill>
+                  <a:srgbClr val="1D2B2A"/>
+                </a:solidFill>
+                <a:latin typeface="Calibri" pitchFamily="34" charset="0"/>
+                <a:ea typeface="Calibri" pitchFamily="34" charset="-122"/>
+                <a:cs typeface="Calibri" pitchFamily="34" charset="-120"/>
+              </a:rPr>
+              <a:t>Bank fees used up customers' savings withdrawals</a:t>
+            </a:r>
+            <a:endParaRPr lang="en-US" sz="1350" dirty="0"/>
+          </a:p>
+          <a:p>
+            <a:pPr marL="342900" indent="-342900">
+              <a:spcAft>
+                <a:spcPts val="600"/>
+              </a:spcAft>
+              <a:buSzPct val="100000"/>
+              <a:buChar char="•"/>
+            </a:pPr>
+            <a:r>
+              <a:rPr lang="en-US" sz="1350" dirty="0">
+                <a:solidFill>
+                  <a:srgbClr val="1D2B2A"/>
+                </a:solidFill>
+                <a:latin typeface="Calibri" pitchFamily="34" charset="0"/>
+                <a:ea typeface="Calibri" pitchFamily="34" charset="-122"/>
+                <a:cs typeface="Calibri" pitchFamily="34" charset="-120"/>
+              </a:rPr>
+              <a:t>Account closure ignored holds and pending payments</a:t>
+            </a:r>
+            <a:endParaRPr lang="en-US" sz="1350" dirty="0"/>
+          </a:p>
+          <a:p>
+            <a:pPr marL="342900" indent="-342900">
+              <a:spcAft>
+                <a:spcPts val="600"/>
+              </a:spcAft>
+              <a:buSzPct val="100000"/>
+              <a:buChar char="•"/>
+            </a:pPr>
+            <a:r>
+              <a:rPr lang="en-US" sz="1350" dirty="0">
+                <a:solidFill>
+                  <a:srgbClr val="1D2B2A"/>
+                </a:solidFill>
+                <a:latin typeface="Calibri" pitchFamily="34" charset="0"/>
+                <a:ea typeface="Calibri" pitchFamily="34" charset="-122"/>
+                <a:cs typeface="Calibri" pitchFamily="34" charset="-120"/>
+              </a:rPr>
+              <a:t>No delegated limit on credit approvals</a:t>
+            </a:r>
+            <a:endParaRPr lang="en-US" sz="1350" dirty="0"/>
+          </a:p>
+        </p:txBody>
+      </p:sp>
+    </p:spTree>
+  </p:cSld>
+  <p:clrMapOvr>
+    <a:masterClrMapping/>
+  </p:clrMapOvr>
+</p:sld>
+</file>
+
+<file path=ppt/slides/slide13.xml><?xml version="1.0" encoding="utf-8"?>
+<p:sld xmlns:a="http://schemas.openxmlformats.org/drawingml/2006/main" xmlns:r="http://schemas.openxmlformats.org/officeDocument/2006/relationships" xmlns:p="http://schemas.openxmlformats.org/presentationml/2006/main">
+  <p:cSld name="Slide 13">
     <p:bg>
       <p:bgPr>
         <a:solidFill>

</xml_diff>

<commit_message>
Add flowcharts, portable build tools and GUI fixes
- Six flowcharts with the standard symbols (terminator, process,
  decision, input/output, predefined process, data store), traced from
  the code: program, onboarding, transfer, card purchase, financing, GUI
- tools/: flowchart generator, SVG->PNG renderer, report PDF and Word
  builders, deck generator, GUI screenshots and a GUI smoke test that
  drives every check, every form and an onboarding story
- GUI: operation forms now follow "Reset data" (CurrentBank proxy; they
  previously kept acting on the discarded bank); clearer message for a
  non-numeric amount; Diagrams screen scrolls with the mouse wheel
- Report section 4.1 (flowcharts) and updated section 11; README,
  checklist, viva notes and a 14-slide deck with a flowchart slide

Co-Authored-By: Claude Opus 5.5 <noreply@anthropic.com>
Claude-Session: https://claude.ai/code/session_01SahYJB3mwF36eBHRbWfj6o
</commit_message>
<xml_diff>
--- a/docs/Viva_Presentation.pptx
+++ b/docs/Viva_Presentation.pptx
@@ -18,9 +18,10 @@
     <p:sldId id="266" r:id="rId12"/>
     <p:sldId id="267" r:id="rId13"/>
     <p:sldId id="268" r:id="rId14"/>
+    <p:sldId id="269" r:id="rId15"/>
   </p:sldIdLst>
   <p:notesMasterIdLst>
-    <p:notesMasterId r:id="rId15"/>
+    <p:notesMasterId r:id="rId16"/>
   </p:notesMasterIdLst>
   <p:sldSz cx="9144000" cy="5143500"/>
   <p:notesSz cx="5143500" cy="9144000"/>
@@ -690,7 +691,7 @@
           <a:p>
             <a:r>
               <a:rPr lang="en-US" dirty="0"/>
-              <a:t>Run Operations &gt; Guided rule checks in order. Then Customers: Ayesha's roles as ribbons, and the time machine on 11 April 2026. The GUI contains no business rules: refusals come from the model and name its error class.</a:t>
+              <a:t>The class diagrams show structure; the flowcharts show behaviour. Walk through the transfer: beneficiary, authority (mandate within limit), funds, dual control, then the PKR 1,000,000 compliance hold. Every red terminator is a refusal that is still kept on record.</a:t>
             </a:r>
             <a:endParaRPr lang="en-US" dirty="0"/>
           </a:p>
@@ -778,7 +779,7 @@
           <a:p>
             <a:r>
               <a:rPr lang="en-US" dirty="0"/>
-              <a:t>Full table in docs/Code_Review.md. Every fix is protected by a test, so it cannot silently come back.</a:t>
+              <a:t>Run Operations &gt; Guided rule checks in order. Then Customers: Ayesha's roles as ribbons, and the time machine on 11 April 2026. The GUI contains no business rules: refusals come from the model and name its error class.</a:t>
             </a:r>
             <a:endParaRPr lang="en-US" dirty="0"/>
           </a:p>
@@ -866,7 +867,7 @@
           <a:p>
             <a:r>
               <a:rPr lang="en-US" dirty="0"/>
-              <a:t>The Arrangement level is where the design pays off for new business models: an Ijarah or Murabaha contract is a new kind of arrangement, not a change to existing classes.</a:t>
+              <a:t>Full table in docs/Code_Review.md. Every fix is protected by a test, so it cannot silently come back.</a:t>
             </a:r>
             <a:endParaRPr lang="en-US" dirty="0"/>
           </a:p>
@@ -890,6 +891,94 @@
             <a:fld id="{F7021451-1387-4CA6-816F-3879F97B5CBC}" type="slidenum">
               <a:rPr lang="en-US"/>
               <a:t>13</a:t>
+            </a:fld>
+            <a:endParaRPr lang="en-US"/>
+          </a:p>
+        </p:txBody>
+      </p:sp>
+    </p:spTree>
+    <p:extLst>
+      <p:ext uri="{BB962C8B-B14F-4D97-AF65-F5344CB8AC3E}">
+        <p14:creationId xmlns:p14="http://schemas.microsoft.com/office/powerpoint/2010/main" val="1024086991"/>
+      </p:ext>
+    </p:extLst>
+  </p:cSld>
+  <p:clrMapOvr>
+    <a:masterClrMapping/>
+  </p:clrMapOvr>
+</p:notes>
+</file>
+
+<file path=ppt/notesSlides/notesSlide14.xml><?xml version="1.0" encoding="utf-8"?>
+<p:notes xmlns:a="http://schemas.openxmlformats.org/drawingml/2006/main" xmlns:r="http://schemas.openxmlformats.org/officeDocument/2006/relationships" xmlns:p="http://schemas.openxmlformats.org/presentationml/2006/main">
+  <p:cSld>
+    <p:spTree>
+      <p:nvGrpSpPr>
+        <p:cNvPr id="1" name=""/>
+        <p:cNvGrpSpPr/>
+        <p:nvPr/>
+      </p:nvGrpSpPr>
+      <p:grpSpPr>
+        <a:xfrm>
+          <a:off x="0" y="0"/>
+          <a:ext cx="0" cy="0"/>
+          <a:chOff x="0" y="0"/>
+          <a:chExt cx="0" cy="0"/>
+        </a:xfrm>
+      </p:grpSpPr>
+      <p:sp>
+        <p:nvSpPr>
+          <p:cNvPr id="2" name="Slide Image Placeholder 1"/>
+          <p:cNvSpPr>
+            <a:spLocks noGrp="1" noRot="1" noChangeAspect="1"/>
+          </p:cNvSpPr>
+          <p:nvPr>
+            <p:ph type="sldImg"/>
+          </p:nvPr>
+        </p:nvSpPr>
+        <p:spPr/>
+      </p:sp>
+      <p:sp>
+        <p:nvSpPr>
+          <p:cNvPr id="3" name="Notes Placeholder 2"/>
+          <p:cNvSpPr>
+            <a:spLocks noGrp="1"/>
+          </p:cNvSpPr>
+          <p:nvPr>
+            <p:ph type="body" idx="1"/>
+          </p:nvPr>
+        </p:nvSpPr>
+        <p:spPr/>
+        <p:txBody>
+          <a:bodyPr/>
+          <a:lstStyle/>
+          <a:p>
+            <a:r>
+              <a:rPr lang="en-US" dirty="0"/>
+              <a:t>The Arrangement level is where the design pays off for new business models: an Ijarah or Murabaha contract is a new kind of arrangement, not a change to existing classes.</a:t>
+            </a:r>
+            <a:endParaRPr lang="en-US" dirty="0"/>
+          </a:p>
+        </p:txBody>
+      </p:sp>
+      <p:sp>
+        <p:nvSpPr>
+          <p:cNvPr id="4" name="Slide Number Placeholder 3"/>
+          <p:cNvSpPr>
+            <a:spLocks noGrp="1"/>
+          </p:cNvSpPr>
+          <p:nvPr>
+            <p:ph type="sldNum" sz="quarter" idx="10"/>
+          </p:nvPr>
+        </p:nvSpPr>
+        <p:spPr/>
+        <p:txBody>
+          <a:bodyPr/>
+          <a:lstStyle/>
+          <a:p>
+            <a:fld id="{F7021451-1387-4CA6-816F-3879F97B5CBC}" type="slidenum">
+              <a:rPr lang="en-US"/>
+              <a:t>14</a:t>
             </a:fld>
             <a:endParaRPr lang="en-US"/>
           </a:p>
@@ -2934,7 +3023,7 @@
               <a:buNone/>
             </a:pPr>
             <a:r>
-              <a:rPr lang="en-US" sz="2800" b="1" dirty="0">
+              <a:rPr lang="en-US" sz="2200" b="1" dirty="0">
                 <a:solidFill>
                   <a:srgbClr val="0B4F4A"/>
                 </a:solidFill>
@@ -2942,9 +3031,9 @@
                 <a:ea typeface="Cambria" pitchFamily="34" charset="-122"/>
                 <a:cs typeface="Cambria" pitchFamily="34" charset="-120"/>
               </a:rPr>
-              <a:t>Live demo: the desktop console</a:t>
-            </a:r>
-            <a:endParaRPr lang="en-US" sz="2800" dirty="0"/>
+              <a:t>Behaviour: six flowcharts traced from the code</a:t>
+            </a:r>
+            <a:endParaRPr lang="en-US" sz="2200" dirty="0"/>
           </a:p>
         </p:txBody>
       </p:sp>
@@ -2981,7 +3070,7 @@
                 <a:ea typeface="Calibri" pitchFamily="34" charset="-122"/>
                 <a:cs typeface="Calibri" pitchFamily="34" charset="-120"/>
               </a:rPr>
-              <a:t>banking_gui.py - pure Python (Tkinter); every button calls one Bank operation</a:t>
+              <a:t>Standard symbols (ISO 5807); the diamonds are in the order the code checks the rules</a:t>
             </a:r>
             <a:endParaRPr lang="en-US" sz="1200" dirty="0"/>
           </a:p>
@@ -2996,11 +3085,11 @@
         <p:spPr>
           <a:xfrm>
             <a:off x="457200" y="1188720"/>
-            <a:ext cx="5577840" cy="3611880"/>
+            <a:ext cx="3200400" cy="3611880"/>
           </a:xfrm>
           <a:prstGeom prst="roundRect">
             <a:avLst>
-              <a:gd name="adj" fmla="val 2025"/>
+              <a:gd name="adj" fmla="val 2286"/>
             </a:avLst>
           </a:prstGeom>
           <a:solidFill>
@@ -3016,7 +3105,7 @@
       </p:sp>
       <p:pic>
         <p:nvPicPr>
-          <p:cNvPr id="5" name="Image 0" descr="/home/user/commercial-banking/docs/screenshots/gui_01_overview.png">    </p:cNvPr>
+          <p:cNvPr id="5" name="Image 0" descr="/home/user/commercial-banking/docs/flowchart_3_transfer.png">    </p:cNvPr>
           <p:cNvPicPr>
             <a:picLocks noChangeAspect="1"/>
           </p:cNvPicPr>
@@ -3030,8 +3119,8 @@
         </p:blipFill>
         <p:spPr>
           <a:xfrm>
-            <a:off x="548640" y="1280160"/>
-            <a:ext cx="5394960" cy="3291840"/>
+            <a:off x="782195" y="1261872"/>
+            <a:ext cx="2550410" cy="3474720"/>
           </a:xfrm>
           <a:prstGeom prst="rect">
             <a:avLst/>
@@ -3040,31 +3129,414 @@
       </p:pic>
       <p:sp>
         <p:nvSpPr>
-          <p:cNvPr id="6" name="Text 3"/>
-          <p:cNvSpPr txBox="1"/>
-          <p:nvPr/>
-        </p:nvSpPr>
-        <p:spPr>
-          <a:xfrm>
-            <a:off x="6263640" y="1234440"/>
-            <a:ext cx="2468880" cy="3566160"/>
-          </a:xfrm>
-          <a:prstGeom prst="rect">
-            <a:avLst/>
-          </a:prstGeom>
-          <a:noFill/>
-          <a:ln/>
-        </p:spPr>
-        <p:txBody>
-          <a:bodyPr wrap="square" lIns="635" tIns="635" rIns="635" bIns="635" rtlCol="0" anchor="t"/>
-          <a:lstStyle/>
-          <a:p>
-            <a:pPr marL="342900" indent="-342900">
+          <p:cNvPr id="6" name="Shape 3"/>
+          <p:cNvSpPr/>
+          <p:nvPr/>
+        </p:nvSpPr>
+        <p:spPr>
+          <a:xfrm>
+            <a:off x="3931920" y="1234440"/>
+            <a:ext cx="640080" cy="329184"/>
+          </a:xfrm>
+          <a:prstGeom prst="flowChartTerminator">
+            <a:avLst/>
+          </a:prstGeom>
+          <a:solidFill>
+            <a:srgbClr val="E8F0EE"/>
+          </a:solidFill>
+          <a:ln w="12700">
+            <a:solidFill>
+              <a:srgbClr val="0B4F4A"/>
+            </a:solidFill>
+            <a:prstDash val="solid"/>
+          </a:ln>
+        </p:spPr>
+      </p:sp>
+      <p:sp>
+        <p:nvSpPr>
+          <p:cNvPr id="7" name="Text 4"/>
+          <p:cNvSpPr txBox="1"/>
+          <p:nvPr/>
+        </p:nvSpPr>
+        <p:spPr>
+          <a:xfrm>
+            <a:off x="4663440" y="1234440"/>
+            <a:ext cx="1874520" cy="329184"/>
+          </a:xfrm>
+          <a:prstGeom prst="rect">
+            <a:avLst/>
+          </a:prstGeom>
+          <a:noFill/>
+          <a:ln/>
+        </p:spPr>
+        <p:txBody>
+          <a:bodyPr wrap="square" lIns="0" tIns="0" rIns="0" bIns="0" rtlCol="0" anchor="ctr"/>
+          <a:lstStyle/>
+          <a:p>
+            <a:pPr indent="0" marL="0">
+              <a:buNone/>
+            </a:pPr>
+            <a:r>
+              <a:rPr lang="en-US" sz="1100" dirty="0">
+                <a:solidFill>
+                  <a:srgbClr val="1D2B2A"/>
+                </a:solidFill>
+                <a:latin typeface="Calibri" pitchFamily="34" charset="0"/>
+                <a:ea typeface="Calibri" pitchFamily="34" charset="-122"/>
+                <a:cs typeface="Calibri" pitchFamily="34" charset="-120"/>
+              </a:rPr>
+              <a:t>Start / end; red = refused</a:t>
+            </a:r>
+            <a:endParaRPr lang="en-US" sz="1100" dirty="0"/>
+          </a:p>
+        </p:txBody>
+      </p:sp>
+      <p:sp>
+        <p:nvSpPr>
+          <p:cNvPr id="8" name="Shape 5"/>
+          <p:cNvSpPr/>
+          <p:nvPr/>
+        </p:nvSpPr>
+        <p:spPr>
+          <a:xfrm>
+            <a:off x="3931920" y="1664208"/>
+            <a:ext cx="640080" cy="329184"/>
+          </a:xfrm>
+          <a:prstGeom prst="flowChartProcess">
+            <a:avLst/>
+          </a:prstGeom>
+          <a:solidFill>
+            <a:srgbClr val="E8F0EE"/>
+          </a:solidFill>
+          <a:ln w="12700">
+            <a:solidFill>
+              <a:srgbClr val="0B4F4A"/>
+            </a:solidFill>
+            <a:prstDash val="solid"/>
+          </a:ln>
+        </p:spPr>
+      </p:sp>
+      <p:sp>
+        <p:nvSpPr>
+          <p:cNvPr id="9" name="Text 6"/>
+          <p:cNvSpPr txBox="1"/>
+          <p:nvPr/>
+        </p:nvSpPr>
+        <p:spPr>
+          <a:xfrm>
+            <a:off x="4663440" y="1664208"/>
+            <a:ext cx="1874520" cy="329184"/>
+          </a:xfrm>
+          <a:prstGeom prst="rect">
+            <a:avLst/>
+          </a:prstGeom>
+          <a:noFill/>
+          <a:ln/>
+        </p:spPr>
+        <p:txBody>
+          <a:bodyPr wrap="square" lIns="0" tIns="0" rIns="0" bIns="0" rtlCol="0" anchor="ctr"/>
+          <a:lstStyle/>
+          <a:p>
+            <a:pPr indent="0" marL="0">
+              <a:buNone/>
+            </a:pPr>
+            <a:r>
+              <a:rPr lang="en-US" sz="1100" dirty="0">
+                <a:solidFill>
+                  <a:srgbClr val="1D2B2A"/>
+                </a:solidFill>
+                <a:latin typeface="Calibri" pitchFamily="34" charset="0"/>
+                <a:ea typeface="Calibri" pitchFamily="34" charset="-122"/>
+                <a:cs typeface="Calibri" pitchFamily="34" charset="-120"/>
+              </a:rPr>
+              <a:t>Process: one step</a:t>
+            </a:r>
+            <a:endParaRPr lang="en-US" sz="1100" dirty="0"/>
+          </a:p>
+        </p:txBody>
+      </p:sp>
+      <p:sp>
+        <p:nvSpPr>
+          <p:cNvPr id="10" name="Shape 7"/>
+          <p:cNvSpPr/>
+          <p:nvPr/>
+        </p:nvSpPr>
+        <p:spPr>
+          <a:xfrm>
+            <a:off x="3931920" y="2093976"/>
+            <a:ext cx="640080" cy="329184"/>
+          </a:xfrm>
+          <a:prstGeom prst="flowChartDecision">
+            <a:avLst/>
+          </a:prstGeom>
+          <a:solidFill>
+            <a:srgbClr val="FDF1D6"/>
+          </a:solidFill>
+          <a:ln w="12700">
+            <a:solidFill>
+              <a:srgbClr val="0B4F4A"/>
+            </a:solidFill>
+            <a:prstDash val="solid"/>
+          </a:ln>
+        </p:spPr>
+      </p:sp>
+      <p:sp>
+        <p:nvSpPr>
+          <p:cNvPr id="11" name="Text 8"/>
+          <p:cNvSpPr txBox="1"/>
+          <p:nvPr/>
+        </p:nvSpPr>
+        <p:spPr>
+          <a:xfrm>
+            <a:off x="4663440" y="2093976"/>
+            <a:ext cx="1874520" cy="329184"/>
+          </a:xfrm>
+          <a:prstGeom prst="rect">
+            <a:avLst/>
+          </a:prstGeom>
+          <a:noFill/>
+          <a:ln/>
+        </p:spPr>
+        <p:txBody>
+          <a:bodyPr wrap="square" lIns="0" tIns="0" rIns="0" bIns="0" rtlCol="0" anchor="ctr"/>
+          <a:lstStyle/>
+          <a:p>
+            <a:pPr indent="0" marL="0">
+              <a:buNone/>
+            </a:pPr>
+            <a:r>
+              <a:rPr lang="en-US" sz="1100" dirty="0">
+                <a:solidFill>
+                  <a:srgbClr val="1D2B2A"/>
+                </a:solidFill>
+                <a:latin typeface="Calibri" pitchFamily="34" charset="0"/>
+                <a:ea typeface="Calibri" pitchFamily="34" charset="-122"/>
+                <a:cs typeface="Calibri" pitchFamily="34" charset="-120"/>
+              </a:rPr>
+              <a:t>Decision: Yes / No</a:t>
+            </a:r>
+            <a:endParaRPr lang="en-US" sz="1100" dirty="0"/>
+          </a:p>
+        </p:txBody>
+      </p:sp>
+      <p:sp>
+        <p:nvSpPr>
+          <p:cNvPr id="12" name="Shape 9"/>
+          <p:cNvSpPr/>
+          <p:nvPr/>
+        </p:nvSpPr>
+        <p:spPr>
+          <a:xfrm>
+            <a:off x="3931920" y="2523744"/>
+            <a:ext cx="640080" cy="329184"/>
+          </a:xfrm>
+          <a:prstGeom prst="flowChartInputOutput">
+            <a:avLst/>
+          </a:prstGeom>
+          <a:solidFill>
+            <a:srgbClr val="E8F0EE"/>
+          </a:solidFill>
+          <a:ln w="12700">
+            <a:solidFill>
+              <a:srgbClr val="0B4F4A"/>
+            </a:solidFill>
+            <a:prstDash val="solid"/>
+          </a:ln>
+        </p:spPr>
+      </p:sp>
+      <p:sp>
+        <p:nvSpPr>
+          <p:cNvPr id="13" name="Text 10"/>
+          <p:cNvSpPr txBox="1"/>
+          <p:nvPr/>
+        </p:nvSpPr>
+        <p:spPr>
+          <a:xfrm>
+            <a:off x="4663440" y="2523744"/>
+            <a:ext cx="1874520" cy="329184"/>
+          </a:xfrm>
+          <a:prstGeom prst="rect">
+            <a:avLst/>
+          </a:prstGeom>
+          <a:noFill/>
+          <a:ln/>
+        </p:spPr>
+        <p:txBody>
+          <a:bodyPr wrap="square" lIns="0" tIns="0" rIns="0" bIns="0" rtlCol="0" anchor="ctr"/>
+          <a:lstStyle/>
+          <a:p>
+            <a:pPr indent="0" marL="0">
+              <a:buNone/>
+            </a:pPr>
+            <a:r>
+              <a:rPr lang="en-US" sz="1100" dirty="0">
+                <a:solidFill>
+                  <a:srgbClr val="1D2B2A"/>
+                </a:solidFill>
+                <a:latin typeface="Calibri" pitchFamily="34" charset="0"/>
+                <a:ea typeface="Calibri" pitchFamily="34" charset="-122"/>
+                <a:cs typeface="Calibri" pitchFamily="34" charset="-120"/>
+              </a:rPr>
+              <a:t>Input / output</a:t>
+            </a:r>
+            <a:endParaRPr lang="en-US" sz="1100" dirty="0"/>
+          </a:p>
+        </p:txBody>
+      </p:sp>
+      <p:sp>
+        <p:nvSpPr>
+          <p:cNvPr id="14" name="Shape 11"/>
+          <p:cNvSpPr/>
+          <p:nvPr/>
+        </p:nvSpPr>
+        <p:spPr>
+          <a:xfrm>
+            <a:off x="3931920" y="2953512"/>
+            <a:ext cx="640080" cy="329184"/>
+          </a:xfrm>
+          <a:prstGeom prst="flowChartPredefinedProcess">
+            <a:avLst/>
+          </a:prstGeom>
+          <a:solidFill>
+            <a:srgbClr val="E8F0EE"/>
+          </a:solidFill>
+          <a:ln w="12700">
+            <a:solidFill>
+              <a:srgbClr val="0B4F4A"/>
+            </a:solidFill>
+            <a:prstDash val="solid"/>
+          </a:ln>
+        </p:spPr>
+      </p:sp>
+      <p:sp>
+        <p:nvSpPr>
+          <p:cNvPr id="15" name="Text 12"/>
+          <p:cNvSpPr txBox="1"/>
+          <p:nvPr/>
+        </p:nvSpPr>
+        <p:spPr>
+          <a:xfrm>
+            <a:off x="4663440" y="2953512"/>
+            <a:ext cx="1874520" cy="329184"/>
+          </a:xfrm>
+          <a:prstGeom prst="rect">
+            <a:avLst/>
+          </a:prstGeom>
+          <a:noFill/>
+          <a:ln/>
+        </p:spPr>
+        <p:txBody>
+          <a:bodyPr wrap="square" lIns="0" tIns="0" rIns="0" bIns="0" rtlCol="0" anchor="ctr"/>
+          <a:lstStyle/>
+          <a:p>
+            <a:pPr indent="0" marL="0">
+              <a:buNone/>
+            </a:pPr>
+            <a:r>
+              <a:rPr lang="en-US" sz="1100" dirty="0">
+                <a:solidFill>
+                  <a:srgbClr val="1D2B2A"/>
+                </a:solidFill>
+                <a:latin typeface="Calibri" pitchFamily="34" charset="0"/>
+                <a:ea typeface="Calibri" pitchFamily="34" charset="-122"/>
+                <a:cs typeface="Calibri" pitchFamily="34" charset="-120"/>
+              </a:rPr>
+              <a:t>A named Bank operation</a:t>
+            </a:r>
+            <a:endParaRPr lang="en-US" sz="1100" dirty="0"/>
+          </a:p>
+        </p:txBody>
+      </p:sp>
+      <p:sp>
+        <p:nvSpPr>
+          <p:cNvPr id="16" name="Shape 13"/>
+          <p:cNvSpPr/>
+          <p:nvPr/>
+        </p:nvSpPr>
+        <p:spPr>
+          <a:xfrm>
+            <a:off x="3931920" y="3383280"/>
+            <a:ext cx="640080" cy="329184"/>
+          </a:xfrm>
+          <a:prstGeom prst="flowChartMagneticDisk">
+            <a:avLst/>
+          </a:prstGeom>
+          <a:solidFill>
+            <a:srgbClr val="E8F0EE"/>
+          </a:solidFill>
+          <a:ln w="12700">
+            <a:solidFill>
+              <a:srgbClr val="0B4F4A"/>
+            </a:solidFill>
+            <a:prstDash val="solid"/>
+          </a:ln>
+        </p:spPr>
+      </p:sp>
+      <p:sp>
+        <p:nvSpPr>
+          <p:cNvPr id="17" name="Text 14"/>
+          <p:cNvSpPr txBox="1"/>
+          <p:nvPr/>
+        </p:nvSpPr>
+        <p:spPr>
+          <a:xfrm>
+            <a:off x="4663440" y="3383280"/>
+            <a:ext cx="1874520" cy="329184"/>
+          </a:xfrm>
+          <a:prstGeom prst="rect">
+            <a:avLst/>
+          </a:prstGeom>
+          <a:noFill/>
+          <a:ln/>
+        </p:spPr>
+        <p:txBody>
+          <a:bodyPr wrap="square" lIns="0" tIns="0" rIns="0" bIns="0" rtlCol="0" anchor="ctr"/>
+          <a:lstStyle/>
+          <a:p>
+            <a:pPr indent="0" marL="0">
+              <a:buNone/>
+            </a:pPr>
+            <a:r>
+              <a:rPr lang="en-US" sz="1100" dirty="0">
+                <a:solidFill>
+                  <a:srgbClr val="1D2B2A"/>
+                </a:solidFill>
+                <a:latin typeface="Calibri" pitchFamily="34" charset="0"/>
+                <a:ea typeface="Calibri" pitchFamily="34" charset="-122"/>
+                <a:cs typeface="Calibri" pitchFamily="34" charset="-120"/>
+              </a:rPr>
+              <a:t>Ledger / audit log</a:t>
+            </a:r>
+            <a:endParaRPr lang="en-US" sz="1100" dirty="0"/>
+          </a:p>
+        </p:txBody>
+      </p:sp>
+      <p:sp>
+        <p:nvSpPr>
+          <p:cNvPr id="18" name="Text 15"/>
+          <p:cNvSpPr txBox="1"/>
+          <p:nvPr/>
+        </p:nvSpPr>
+        <p:spPr>
+          <a:xfrm>
+            <a:off x="6720840" y="1234440"/>
+            <a:ext cx="1965960" cy="2560320"/>
+          </a:xfrm>
+          <a:prstGeom prst="rect">
+            <a:avLst/>
+          </a:prstGeom>
+          <a:noFill/>
+          <a:ln/>
+        </p:spPr>
+        <p:txBody>
+          <a:bodyPr wrap="square" lIns="0" tIns="0" rIns="0" bIns="0" rtlCol="0" anchor="t"/>
+          <a:lstStyle/>
+          <a:p>
+            <a:pPr indent="0" marL="0">
               <a:spcAft>
                 <a:spcPts val="600"/>
               </a:spcAft>
-              <a:buSzPct val="100000"/>
-              <a:buChar char="•"/>
+              <a:buNone/>
             </a:pPr>
             <a:r>
               <a:rPr lang="en-US" sz="1200" dirty="0">
@@ -3075,17 +3547,16 @@
                 <a:ea typeface="Calibri" pitchFamily="34" charset="-122"/>
                 <a:cs typeface="Calibri" pitchFamily="34" charset="-120"/>
               </a:rPr>
-              <a:t>Guided rule checks: 14 real operations, each showing the model's own refusal</a:t>
+              <a:t>1. Program overview</a:t>
             </a:r>
             <a:endParaRPr lang="en-US" sz="1200" dirty="0"/>
           </a:p>
           <a:p>
-            <a:pPr marL="342900" indent="-342900">
+            <a:pPr indent="0" marL="0">
               <a:spcAft>
                 <a:spcPts val="600"/>
               </a:spcAft>
-              <a:buSzPct val="100000"/>
-              <a:buChar char="•"/>
+              <a:buNone/>
             </a:pPr>
             <a:r>
               <a:rPr lang="en-US" sz="1200" dirty="0">
@@ -3096,17 +3567,16 @@
                 <a:ea typeface="Calibri" pitchFamily="34" charset="-122"/>
                 <a:cs typeface="Calibri" pitchFamily="34" charset="-120"/>
               </a:rPr>
-              <a:t>Customer timeline and time machine for any past date</a:t>
+              <a:t>2. Onboarding</a:t>
             </a:r>
             <a:endParaRPr lang="en-US" sz="1200" dirty="0"/>
           </a:p>
           <a:p>
-            <a:pPr marL="342900" indent="-342900">
+            <a:pPr indent="0" marL="0">
               <a:spcAft>
                 <a:spcPts val="600"/>
               </a:spcAft>
-              <a:buSzPct val="100000"/>
-              <a:buChar char="•"/>
+              <a:buNone/>
             </a:pPr>
             <a:r>
               <a:rPr lang="en-US" sz="1200" dirty="0">
@@ -3117,17 +3587,16 @@
                 <a:ea typeface="Calibri" pitchFamily="34" charset="-122"/>
                 <a:cs typeface="Calibri" pitchFamily="34" charset="-120"/>
               </a:rPr>
-              <a:t>Card chains, cases, audit log and a zero trial balance</a:t>
+              <a:t>3. Transfer payment</a:t>
             </a:r>
             <a:endParaRPr lang="en-US" sz="1200" dirty="0"/>
           </a:p>
           <a:p>
-            <a:pPr marL="342900" indent="-342900">
+            <a:pPr indent="0" marL="0">
               <a:spcAft>
                 <a:spcPts val="600"/>
               </a:spcAft>
-              <a:buSzPct val="100000"/>
-              <a:buChar char="•"/>
+              <a:buNone/>
             </a:pPr>
             <a:r>
               <a:rPr lang="en-US" sz="1200" dirty="0">
@@ -3138,9 +3607,88 @@
                 <a:ea typeface="Calibri" pitchFamily="34" charset="-122"/>
                 <a:cs typeface="Calibri" pitchFamily="34" charset="-120"/>
               </a:rPr>
-              <a:t>GUI classes inherit too: Page -&gt; MasterDetailPage -&gt; CustomersPage</a:t>
+              <a:t>4. Card purchase</a:t>
             </a:r>
             <a:endParaRPr lang="en-US" sz="1200" dirty="0"/>
+          </a:p>
+          <a:p>
+            <a:pPr indent="0" marL="0">
+              <a:spcAft>
+                <a:spcPts val="600"/>
+              </a:spcAft>
+              <a:buNone/>
+            </a:pPr>
+            <a:r>
+              <a:rPr lang="en-US" sz="1200" dirty="0">
+                <a:solidFill>
+                  <a:srgbClr val="1D2B2A"/>
+                </a:solidFill>
+                <a:latin typeface="Calibri" pitchFamily="34" charset="0"/>
+                <a:ea typeface="Calibri" pitchFamily="34" charset="-122"/>
+                <a:cs typeface="Calibri" pitchFamily="34" charset="-120"/>
+              </a:rPr>
+              <a:t>5. Financing lifecycle</a:t>
+            </a:r>
+            <a:endParaRPr lang="en-US" sz="1200" dirty="0"/>
+          </a:p>
+          <a:p>
+            <a:pPr indent="0" marL="0">
+              <a:spcAft>
+                <a:spcPts val="600"/>
+              </a:spcAft>
+              <a:buNone/>
+            </a:pPr>
+            <a:r>
+              <a:rPr lang="en-US" sz="1200" dirty="0">
+                <a:solidFill>
+                  <a:srgbClr val="1D2B2A"/>
+                </a:solidFill>
+                <a:latin typeface="Calibri" pitchFamily="34" charset="0"/>
+                <a:ea typeface="Calibri" pitchFamily="34" charset="-122"/>
+                <a:cs typeface="Calibri" pitchFamily="34" charset="-120"/>
+              </a:rPr>
+              <a:t>6. Desktop console</a:t>
+            </a:r>
+            <a:endParaRPr lang="en-US" sz="1200" dirty="0"/>
+          </a:p>
+        </p:txBody>
+      </p:sp>
+      <p:sp>
+        <p:nvSpPr>
+          <p:cNvPr id="19" name="Text 16"/>
+          <p:cNvSpPr txBox="1"/>
+          <p:nvPr/>
+        </p:nvSpPr>
+        <p:spPr>
+          <a:xfrm>
+            <a:off x="3931920" y="4069080"/>
+            <a:ext cx="4754880" cy="457200"/>
+          </a:xfrm>
+          <a:prstGeom prst="rect">
+            <a:avLst/>
+          </a:prstGeom>
+          <a:noFill/>
+          <a:ln/>
+        </p:spPr>
+        <p:txBody>
+          <a:bodyPr wrap="square" lIns="0" tIns="0" rIns="0" bIns="0" rtlCol="0" anchor="ctr"/>
+          <a:lstStyle/>
+          <a:p>
+            <a:pPr indent="0" marL="0">
+              <a:buNone/>
+            </a:pPr>
+            <a:r>
+              <a:rPr lang="en-US" sz="1100" i="1" dirty="0">
+                <a:solidFill>
+                  <a:srgbClr val="5B6B69"/>
+                </a:solidFill>
+                <a:latin typeface="Calibri" pitchFamily="34" charset="0"/>
+                <a:ea typeface="Calibri" pitchFamily="34" charset="-122"/>
+                <a:cs typeface="Calibri" pitchFamily="34" charset="-120"/>
+              </a:rPr>
+              <a:t>Report section 4.1; also on the GUI's Diagrams screen</a:t>
+            </a:r>
+            <a:endParaRPr lang="en-US" sz="1100" dirty="0"/>
           </a:p>
         </p:txBody>
       </p:sp>
@@ -3203,7 +3751,7 @@
               <a:buNone/>
             </a:pPr>
             <a:r>
-              <a:rPr lang="en-US" sz="2200" b="1" dirty="0">
+              <a:rPr lang="en-US" sz="2800" b="1" dirty="0">
                 <a:solidFill>
                   <a:srgbClr val="0B4F4A"/>
                 </a:solidFill>
@@ -3211,127 +3759,112 @@
                 <a:ea typeface="Cambria" pitchFamily="34" charset="-122"/>
                 <a:cs typeface="Cambria" pitchFamily="34" charset="-120"/>
               </a:rPr>
-              <a:t>Code review: 20 defects fixed, each with a test</a:t>
-            </a:r>
-            <a:endParaRPr lang="en-US" sz="2200" dirty="0"/>
-          </a:p>
-        </p:txBody>
-      </p:sp>
-      <p:sp>
-        <p:nvSpPr>
-          <p:cNvPr id="3" name="Shape 1"/>
+              <a:t>Live demo: the desktop console</a:t>
+            </a:r>
+            <a:endParaRPr lang="en-US" sz="2800" dirty="0"/>
+          </a:p>
+        </p:txBody>
+      </p:sp>
+      <p:sp>
+        <p:nvSpPr>
+          <p:cNvPr id="3" name="Text 1"/>
+          <p:cNvSpPr txBox="1"/>
+          <p:nvPr/>
+        </p:nvSpPr>
+        <p:spPr>
+          <a:xfrm>
+            <a:off x="457200" y="804672"/>
+            <a:ext cx="8229600" cy="320040"/>
+          </a:xfrm>
+          <a:prstGeom prst="rect">
+            <a:avLst/>
+          </a:prstGeom>
+          <a:noFill/>
+          <a:ln/>
+        </p:spPr>
+        <p:txBody>
+          <a:bodyPr wrap="square" lIns="0" tIns="0" rIns="0" bIns="0" rtlCol="0" anchor="ctr"/>
+          <a:lstStyle/>
+          <a:p>
+            <a:pPr indent="0" marL="0">
+              <a:buNone/>
+            </a:pPr>
+            <a:r>
+              <a:rPr lang="en-US" sz="1200" i="1" dirty="0">
+                <a:solidFill>
+                  <a:srgbClr val="5B6B69"/>
+                </a:solidFill>
+                <a:latin typeface="Calibri" pitchFamily="34" charset="0"/>
+                <a:ea typeface="Calibri" pitchFamily="34" charset="-122"/>
+                <a:cs typeface="Calibri" pitchFamily="34" charset="-120"/>
+              </a:rPr>
+              <a:t>banking_gui.py - pure Python (Tkinter); every button calls one Bank operation</a:t>
+            </a:r>
+            <a:endParaRPr lang="en-US" sz="1200" dirty="0"/>
+          </a:p>
+        </p:txBody>
+      </p:sp>
+      <p:sp>
+        <p:nvSpPr>
+          <p:cNvPr id="4" name="Shape 2"/>
           <p:cNvSpPr/>
           <p:nvPr/>
         </p:nvSpPr>
         <p:spPr>
           <a:xfrm>
-            <a:off x="457200" y="1097280"/>
-            <a:ext cx="2651760" cy="3566160"/>
+            <a:off x="457200" y="1188720"/>
+            <a:ext cx="5577840" cy="3611880"/>
           </a:xfrm>
           <a:prstGeom prst="roundRect">
             <a:avLst>
-              <a:gd name="adj" fmla="val 2759"/>
+              <a:gd name="adj" fmla="val 2025"/>
             </a:avLst>
           </a:prstGeom>
           <a:solidFill>
-            <a:srgbClr val="0B4F4A"/>
+            <a:srgbClr val="F4F8F7"/>
           </a:solidFill>
           <a:ln w="12700">
             <a:solidFill>
-              <a:srgbClr val="0B4F4A"/>
+              <a:srgbClr val="F4F8F7"/>
             </a:solidFill>
             <a:prstDash val="solid"/>
           </a:ln>
         </p:spPr>
       </p:sp>
-      <p:sp>
-        <p:nvSpPr>
-          <p:cNvPr id="4" name="Text 2"/>
-          <p:cNvSpPr txBox="1"/>
-          <p:nvPr/>
-        </p:nvSpPr>
-        <p:spPr>
-          <a:xfrm>
-            <a:off x="457200" y="1463040"/>
-            <a:ext cx="2651760" cy="1097280"/>
-          </a:xfrm>
-          <a:prstGeom prst="rect">
-            <a:avLst/>
-          </a:prstGeom>
-          <a:noFill/>
-          <a:ln/>
-        </p:spPr>
-        <p:txBody>
-          <a:bodyPr wrap="square" lIns="0" tIns="0" rIns="0" bIns="0" rtlCol="0" anchor="ctr"/>
-          <a:lstStyle/>
-          <a:p>
-            <a:pPr algn="ctr" indent="0" marL="0">
-              <a:buNone/>
-            </a:pPr>
-            <a:r>
-              <a:rPr lang="en-US" sz="6000" b="1" dirty="0">
-                <a:solidFill>
-                  <a:srgbClr val="FFFFFF"/>
-                </a:solidFill>
-                <a:latin typeface="Cambria" pitchFamily="34" charset="0"/>
-                <a:ea typeface="Cambria" pitchFamily="34" charset="-122"/>
-                <a:cs typeface="Cambria" pitchFamily="34" charset="-120"/>
-              </a:rPr>
-              <a:t>20</a:t>
-            </a:r>
-            <a:endParaRPr lang="en-US" sz="6000" dirty="0"/>
-          </a:p>
-        </p:txBody>
-      </p:sp>
-      <p:sp>
-        <p:nvSpPr>
-          <p:cNvPr id="5" name="Text 3"/>
-          <p:cNvSpPr txBox="1"/>
-          <p:nvPr/>
-        </p:nvSpPr>
-        <p:spPr>
-          <a:xfrm>
-            <a:off x="685800" y="2651760"/>
-            <a:ext cx="2194560" cy="1097280"/>
-          </a:xfrm>
-          <a:prstGeom prst="rect">
-            <a:avLst/>
-          </a:prstGeom>
-          <a:noFill/>
-          <a:ln/>
-        </p:spPr>
-        <p:txBody>
-          <a:bodyPr wrap="square" lIns="0" tIns="0" rIns="0" bIns="0" rtlCol="0" anchor="ctr"/>
-          <a:lstStyle/>
-          <a:p>
-            <a:pPr algn="ctr" indent="0" marL="0">
-              <a:buNone/>
-            </a:pPr>
-            <a:r>
-              <a:rPr lang="en-US" sz="1400" dirty="0">
-                <a:solidFill>
-                  <a:srgbClr val="CFE3DF"/>
-                </a:solidFill>
-                <a:latin typeface="Calibri" pitchFamily="34" charset="0"/>
-                <a:ea typeface="Calibri" pitchFamily="34" charset="-122"/>
-                <a:cs typeface="Calibri" pitchFamily="34" charset="-120"/>
-              </a:rPr>
-              <a:t>defects found and fixed, each with a regression test</a:t>
-            </a:r>
-            <a:endParaRPr lang="en-US" sz="1400" dirty="0"/>
-          </a:p>
-        </p:txBody>
-      </p:sp>
-      <p:sp>
-        <p:nvSpPr>
-          <p:cNvPr id="6" name="Text 4"/>
-          <p:cNvSpPr txBox="1"/>
-          <p:nvPr/>
-        </p:nvSpPr>
-        <p:spPr>
-          <a:xfrm>
-            <a:off x="3474720" y="1143000"/>
-            <a:ext cx="5212080" cy="3566160"/>
+      <p:pic>
+        <p:nvPicPr>
+          <p:cNvPr id="5" name="Image 0" descr="/home/user/commercial-banking/docs/screenshots/gui_01_overview.png">    </p:cNvPr>
+          <p:cNvPicPr>
+            <a:picLocks noChangeAspect="1"/>
+          </p:cNvPicPr>
+          <p:nvPr/>
+        </p:nvPicPr>
+        <p:blipFill>
+          <a:blip r:embed="rId1"/>
+          <a:stretch>
+            <a:fillRect/>
+          </a:stretch>
+        </p:blipFill>
+        <p:spPr>
+          <a:xfrm>
+            <a:off x="548640" y="1280160"/>
+            <a:ext cx="5394960" cy="3291840"/>
+          </a:xfrm>
+          <a:prstGeom prst="rect">
+            <a:avLst/>
+          </a:prstGeom>
+        </p:spPr>
+      </p:pic>
+      <p:sp>
+        <p:nvSpPr>
+          <p:cNvPr id="6" name="Text 3"/>
+          <p:cNvSpPr txBox="1"/>
+          <p:nvPr/>
+        </p:nvSpPr>
+        <p:spPr>
+          <a:xfrm>
+            <a:off x="6263640" y="1234440"/>
+            <a:ext cx="2468880" cy="3566160"/>
           </a:xfrm>
           <a:prstGeom prst="rect">
             <a:avLst/>
@@ -3351,7 +3884,7 @@
               <a:buChar char="•"/>
             </a:pPr>
             <a:r>
-              <a:rPr lang="en-US" sz="1350" dirty="0">
+              <a:rPr lang="en-US" sz="1200" dirty="0">
                 <a:solidFill>
                   <a:srgbClr val="1D2B2A"/>
                 </a:solidFill>
@@ -3359,9 +3892,9 @@
                 <a:ea typeface="Calibri" pitchFamily="34" charset="-122"/>
                 <a:cs typeface="Calibri" pitchFamily="34" charset="-120"/>
               </a:rPr>
-              <a:t>A refused loan overpayment still marked installments as paid</a:t>
-            </a:r>
-            <a:endParaRPr lang="en-US" sz="1350" dirty="0"/>
+              <a:t>Guided rule checks: 14 real operations, each showing the model's own refusal</a:t>
+            </a:r>
+            <a:endParaRPr lang="en-US" sz="1200" dirty="0"/>
           </a:p>
           <a:p>
             <a:pPr marL="342900" indent="-342900">
@@ -3372,7 +3905,7 @@
               <a:buChar char="•"/>
             </a:pPr>
             <a:r>
-              <a:rPr lang="en-US" sz="1350" dirty="0">
+              <a:rPr lang="en-US" sz="1200" dirty="0">
                 <a:solidFill>
                   <a:srgbClr val="1D2B2A"/>
                 </a:solidFill>
@@ -3380,9 +3913,9 @@
                 <a:ea typeface="Calibri" pitchFamily="34" charset="-122"/>
                 <a:cs typeface="Calibri" pitchFamily="34" charset="-120"/>
               </a:rPr>
-              <a:t>Resolving a dispute twice refunded the customer twice</a:t>
-            </a:r>
-            <a:endParaRPr lang="en-US" sz="1350" dirty="0"/>
+              <a:t>30 forms, including full customer onboarding</a:t>
+            </a:r>
+            <a:endParaRPr lang="en-US" sz="1200" dirty="0"/>
           </a:p>
           <a:p>
             <a:pPr marL="342900" indent="-342900">
@@ -3393,7 +3926,7 @@
               <a:buChar char="•"/>
             </a:pPr>
             <a:r>
-              <a:rPr lang="en-US" sz="1350" dirty="0">
+              <a:rPr lang="en-US" sz="1200" dirty="0">
                 <a:solidFill>
                   <a:srgbClr val="1D2B2A"/>
                 </a:solidFill>
@@ -3401,9 +3934,9 @@
                 <a:ea typeface="Calibri" pitchFamily="34" charset="-122"/>
                 <a:cs typeface="Calibri" pitchFamily="34" charset="-120"/>
               </a:rPr>
-              <a:t>Recording an ACTIVE card as found destroyed it</a:t>
-            </a:r>
-            <a:endParaRPr lang="en-US" sz="1350" dirty="0"/>
+              <a:t>Customer timeline and time machine for any past date</a:t>
+            </a:r>
+            <a:endParaRPr lang="en-US" sz="1200" dirty="0"/>
           </a:p>
           <a:p>
             <a:pPr marL="342900" indent="-342900">
@@ -3414,7 +3947,7 @@
               <a:buChar char="•"/>
             </a:pPr>
             <a:r>
-              <a:rPr lang="en-US" sz="1350" dirty="0">
+              <a:rPr lang="en-US" sz="1200" dirty="0">
                 <a:solidFill>
                   <a:srgbClr val="1D2B2A"/>
                 </a:solidFill>
@@ -3422,9 +3955,9 @@
                 <a:ea typeface="Calibri" pitchFamily="34" charset="-122"/>
                 <a:cs typeface="Calibri" pitchFamily="34" charset="-120"/>
               </a:rPr>
-              <a:t>Replacement cards blocked once the product was withdrawn</a:t>
-            </a:r>
-            <a:endParaRPr lang="en-US" sz="1350" dirty="0"/>
+              <a:t>Card chains, cases, audit log and a zero trial balance</a:t>
+            </a:r>
+            <a:endParaRPr lang="en-US" sz="1200" dirty="0"/>
           </a:p>
           <a:p>
             <a:pPr marL="342900" indent="-342900">
@@ -3435,7 +3968,7 @@
               <a:buChar char="•"/>
             </a:pPr>
             <a:r>
-              <a:rPr lang="en-US" sz="1350" dirty="0">
+              <a:rPr lang="en-US" sz="1200" dirty="0">
                 <a:solidFill>
                   <a:srgbClr val="1D2B2A"/>
                 </a:solidFill>
@@ -3443,51 +3976,9 @@
                 <a:ea typeface="Calibri" pitchFamily="34" charset="-122"/>
                 <a:cs typeface="Calibri" pitchFamily="34" charset="-120"/>
               </a:rPr>
-              <a:t>Bank fees used up customers' savings withdrawals</a:t>
-            </a:r>
-            <a:endParaRPr lang="en-US" sz="1350" dirty="0"/>
-          </a:p>
-          <a:p>
-            <a:pPr marL="342900" indent="-342900">
-              <a:spcAft>
-                <a:spcPts val="600"/>
-              </a:spcAft>
-              <a:buSzPct val="100000"/>
-              <a:buChar char="•"/>
-            </a:pPr>
-            <a:r>
-              <a:rPr lang="en-US" sz="1350" dirty="0">
-                <a:solidFill>
-                  <a:srgbClr val="1D2B2A"/>
-                </a:solidFill>
-                <a:latin typeface="Calibri" pitchFamily="34" charset="0"/>
-                <a:ea typeface="Calibri" pitchFamily="34" charset="-122"/>
-                <a:cs typeface="Calibri" pitchFamily="34" charset="-120"/>
-              </a:rPr>
-              <a:t>Account closure ignored holds and pending payments</a:t>
-            </a:r>
-            <a:endParaRPr lang="en-US" sz="1350" dirty="0"/>
-          </a:p>
-          <a:p>
-            <a:pPr marL="342900" indent="-342900">
-              <a:spcAft>
-                <a:spcPts val="600"/>
-              </a:spcAft>
-              <a:buSzPct val="100000"/>
-              <a:buChar char="•"/>
-            </a:pPr>
-            <a:r>
-              <a:rPr lang="en-US" sz="1350" dirty="0">
-                <a:solidFill>
-                  <a:srgbClr val="1D2B2A"/>
-                </a:solidFill>
-                <a:latin typeface="Calibri" pitchFamily="34" charset="0"/>
-                <a:ea typeface="Calibri" pitchFamily="34" charset="-122"/>
-                <a:cs typeface="Calibri" pitchFamily="34" charset="-120"/>
-              </a:rPr>
-              <a:t>No delegated limit on credit approvals</a:t>
-            </a:r>
-            <a:endParaRPr lang="en-US" sz="1350" dirty="0"/>
+              <a:t>GUI classes inherit too: Page -&gt; MasterDetailPage -&gt; CustomersPage</a:t>
+            </a:r>
+            <a:endParaRPr lang="en-US" sz="1200" dirty="0"/>
           </a:p>
         </p:txBody>
       </p:sp>
@@ -3502,6 +3993,353 @@
 <file path=ppt/slides/slide13.xml><?xml version="1.0" encoding="utf-8"?>
 <p:sld xmlns:a="http://schemas.openxmlformats.org/drawingml/2006/main" xmlns:r="http://schemas.openxmlformats.org/officeDocument/2006/relationships" xmlns:p="http://schemas.openxmlformats.org/presentationml/2006/main">
   <p:cSld name="Slide 13">
+    <p:bg>
+      <p:bgPr>
+        <a:solidFill>
+          <a:srgbClr val="FFFFFF"/>
+        </a:solidFill>
+      </p:bgPr>
+    </p:bg>
+    <p:spTree>
+      <p:nvGrpSpPr>
+        <p:cNvPr id="1" name=""/>
+        <p:cNvGrpSpPr/>
+        <p:nvPr/>
+      </p:nvGrpSpPr>
+      <p:grpSpPr>
+        <a:xfrm>
+          <a:off x="0" y="0"/>
+          <a:ext cx="0" cy="0"/>
+          <a:chOff x="0" y="0"/>
+          <a:chExt cx="0" cy="0"/>
+        </a:xfrm>
+      </p:grpSpPr>
+      <p:sp>
+        <p:nvSpPr>
+          <p:cNvPr id="2" name="Text 0"/>
+          <p:cNvSpPr txBox="1"/>
+          <p:nvPr/>
+        </p:nvSpPr>
+        <p:spPr>
+          <a:xfrm>
+            <a:off x="457200" y="274320"/>
+            <a:ext cx="8229600" cy="548640"/>
+          </a:xfrm>
+          <a:prstGeom prst="rect">
+            <a:avLst/>
+          </a:prstGeom>
+          <a:noFill/>
+          <a:ln/>
+        </p:spPr>
+        <p:txBody>
+          <a:bodyPr wrap="square" lIns="0" tIns="0" rIns="0" bIns="0" rtlCol="0" anchor="ctr">
+            <a:normAutofit/>
+          </a:bodyPr>
+          <a:lstStyle/>
+          <a:p>
+            <a:pPr indent="0" marL="0">
+              <a:buNone/>
+            </a:pPr>
+            <a:r>
+              <a:rPr lang="en-US" sz="2200" b="1" dirty="0">
+                <a:solidFill>
+                  <a:srgbClr val="0B4F4A"/>
+                </a:solidFill>
+                <a:latin typeface="Cambria" pitchFamily="34" charset="0"/>
+                <a:ea typeface="Cambria" pitchFamily="34" charset="-122"/>
+                <a:cs typeface="Cambria" pitchFamily="34" charset="-120"/>
+              </a:rPr>
+              <a:t>Code review: 20 defects fixed, each with a test</a:t>
+            </a:r>
+            <a:endParaRPr lang="en-US" sz="2200" dirty="0"/>
+          </a:p>
+        </p:txBody>
+      </p:sp>
+      <p:sp>
+        <p:nvSpPr>
+          <p:cNvPr id="3" name="Shape 1"/>
+          <p:cNvSpPr/>
+          <p:nvPr/>
+        </p:nvSpPr>
+        <p:spPr>
+          <a:xfrm>
+            <a:off x="457200" y="1097280"/>
+            <a:ext cx="2651760" cy="3566160"/>
+          </a:xfrm>
+          <a:prstGeom prst="roundRect">
+            <a:avLst>
+              <a:gd name="adj" fmla="val 2759"/>
+            </a:avLst>
+          </a:prstGeom>
+          <a:solidFill>
+            <a:srgbClr val="0B4F4A"/>
+          </a:solidFill>
+          <a:ln w="12700">
+            <a:solidFill>
+              <a:srgbClr val="0B4F4A"/>
+            </a:solidFill>
+            <a:prstDash val="solid"/>
+          </a:ln>
+        </p:spPr>
+      </p:sp>
+      <p:sp>
+        <p:nvSpPr>
+          <p:cNvPr id="4" name="Text 2"/>
+          <p:cNvSpPr txBox="1"/>
+          <p:nvPr/>
+        </p:nvSpPr>
+        <p:spPr>
+          <a:xfrm>
+            <a:off x="457200" y="1463040"/>
+            <a:ext cx="2651760" cy="1097280"/>
+          </a:xfrm>
+          <a:prstGeom prst="rect">
+            <a:avLst/>
+          </a:prstGeom>
+          <a:noFill/>
+          <a:ln/>
+        </p:spPr>
+        <p:txBody>
+          <a:bodyPr wrap="square" lIns="0" tIns="0" rIns="0" bIns="0" rtlCol="0" anchor="ctr"/>
+          <a:lstStyle/>
+          <a:p>
+            <a:pPr algn="ctr" indent="0" marL="0">
+              <a:buNone/>
+            </a:pPr>
+            <a:r>
+              <a:rPr lang="en-US" sz="6000" b="1" dirty="0">
+                <a:solidFill>
+                  <a:srgbClr val="FFFFFF"/>
+                </a:solidFill>
+                <a:latin typeface="Cambria" pitchFamily="34" charset="0"/>
+                <a:ea typeface="Cambria" pitchFamily="34" charset="-122"/>
+                <a:cs typeface="Cambria" pitchFamily="34" charset="-120"/>
+              </a:rPr>
+              <a:t>20</a:t>
+            </a:r>
+            <a:endParaRPr lang="en-US" sz="6000" dirty="0"/>
+          </a:p>
+        </p:txBody>
+      </p:sp>
+      <p:sp>
+        <p:nvSpPr>
+          <p:cNvPr id="5" name="Text 3"/>
+          <p:cNvSpPr txBox="1"/>
+          <p:nvPr/>
+        </p:nvSpPr>
+        <p:spPr>
+          <a:xfrm>
+            <a:off x="685800" y="2651760"/>
+            <a:ext cx="2194560" cy="1097280"/>
+          </a:xfrm>
+          <a:prstGeom prst="rect">
+            <a:avLst/>
+          </a:prstGeom>
+          <a:noFill/>
+          <a:ln/>
+        </p:spPr>
+        <p:txBody>
+          <a:bodyPr wrap="square" lIns="0" tIns="0" rIns="0" bIns="0" rtlCol="0" anchor="ctr"/>
+          <a:lstStyle/>
+          <a:p>
+            <a:pPr algn="ctr" indent="0" marL="0">
+              <a:buNone/>
+            </a:pPr>
+            <a:r>
+              <a:rPr lang="en-US" sz="1400" dirty="0">
+                <a:solidFill>
+                  <a:srgbClr val="CFE3DF"/>
+                </a:solidFill>
+                <a:latin typeface="Calibri" pitchFamily="34" charset="0"/>
+                <a:ea typeface="Calibri" pitchFamily="34" charset="-122"/>
+                <a:cs typeface="Calibri" pitchFamily="34" charset="-120"/>
+              </a:rPr>
+              <a:t>defects found and fixed, each with a regression test</a:t>
+            </a:r>
+            <a:endParaRPr lang="en-US" sz="1400" dirty="0"/>
+          </a:p>
+        </p:txBody>
+      </p:sp>
+      <p:sp>
+        <p:nvSpPr>
+          <p:cNvPr id="6" name="Text 4"/>
+          <p:cNvSpPr txBox="1"/>
+          <p:nvPr/>
+        </p:nvSpPr>
+        <p:spPr>
+          <a:xfrm>
+            <a:off x="3474720" y="1143000"/>
+            <a:ext cx="5212080" cy="3566160"/>
+          </a:xfrm>
+          <a:prstGeom prst="rect">
+            <a:avLst/>
+          </a:prstGeom>
+          <a:noFill/>
+          <a:ln/>
+        </p:spPr>
+        <p:txBody>
+          <a:bodyPr wrap="square" lIns="635" tIns="635" rIns="635" bIns="635" rtlCol="0" anchor="t"/>
+          <a:lstStyle/>
+          <a:p>
+            <a:pPr marL="342900" indent="-342900">
+              <a:spcAft>
+                <a:spcPts val="600"/>
+              </a:spcAft>
+              <a:buSzPct val="100000"/>
+              <a:buChar char="•"/>
+            </a:pPr>
+            <a:r>
+              <a:rPr lang="en-US" sz="1350" dirty="0">
+                <a:solidFill>
+                  <a:srgbClr val="1D2B2A"/>
+                </a:solidFill>
+                <a:latin typeface="Calibri" pitchFamily="34" charset="0"/>
+                <a:ea typeface="Calibri" pitchFamily="34" charset="-122"/>
+                <a:cs typeface="Calibri" pitchFamily="34" charset="-120"/>
+              </a:rPr>
+              <a:t>A refused loan overpayment still marked installments as paid</a:t>
+            </a:r>
+            <a:endParaRPr lang="en-US" sz="1350" dirty="0"/>
+          </a:p>
+          <a:p>
+            <a:pPr marL="342900" indent="-342900">
+              <a:spcAft>
+                <a:spcPts val="600"/>
+              </a:spcAft>
+              <a:buSzPct val="100000"/>
+              <a:buChar char="•"/>
+            </a:pPr>
+            <a:r>
+              <a:rPr lang="en-US" sz="1350" dirty="0">
+                <a:solidFill>
+                  <a:srgbClr val="1D2B2A"/>
+                </a:solidFill>
+                <a:latin typeface="Calibri" pitchFamily="34" charset="0"/>
+                <a:ea typeface="Calibri" pitchFamily="34" charset="-122"/>
+                <a:cs typeface="Calibri" pitchFamily="34" charset="-120"/>
+              </a:rPr>
+              <a:t>Resolving a dispute twice refunded the customer twice</a:t>
+            </a:r>
+            <a:endParaRPr lang="en-US" sz="1350" dirty="0"/>
+          </a:p>
+          <a:p>
+            <a:pPr marL="342900" indent="-342900">
+              <a:spcAft>
+                <a:spcPts val="600"/>
+              </a:spcAft>
+              <a:buSzPct val="100000"/>
+              <a:buChar char="•"/>
+            </a:pPr>
+            <a:r>
+              <a:rPr lang="en-US" sz="1350" dirty="0">
+                <a:solidFill>
+                  <a:srgbClr val="1D2B2A"/>
+                </a:solidFill>
+                <a:latin typeface="Calibri" pitchFamily="34" charset="0"/>
+                <a:ea typeface="Calibri" pitchFamily="34" charset="-122"/>
+                <a:cs typeface="Calibri" pitchFamily="34" charset="-120"/>
+              </a:rPr>
+              <a:t>Recording an ACTIVE card as found destroyed it</a:t>
+            </a:r>
+            <a:endParaRPr lang="en-US" sz="1350" dirty="0"/>
+          </a:p>
+          <a:p>
+            <a:pPr marL="342900" indent="-342900">
+              <a:spcAft>
+                <a:spcPts val="600"/>
+              </a:spcAft>
+              <a:buSzPct val="100000"/>
+              <a:buChar char="•"/>
+            </a:pPr>
+            <a:r>
+              <a:rPr lang="en-US" sz="1350" dirty="0">
+                <a:solidFill>
+                  <a:srgbClr val="1D2B2A"/>
+                </a:solidFill>
+                <a:latin typeface="Calibri" pitchFamily="34" charset="0"/>
+                <a:ea typeface="Calibri" pitchFamily="34" charset="-122"/>
+                <a:cs typeface="Calibri" pitchFamily="34" charset="-120"/>
+              </a:rPr>
+              <a:t>Replacement cards blocked once the product was withdrawn</a:t>
+            </a:r>
+            <a:endParaRPr lang="en-US" sz="1350" dirty="0"/>
+          </a:p>
+          <a:p>
+            <a:pPr marL="342900" indent="-342900">
+              <a:spcAft>
+                <a:spcPts val="600"/>
+              </a:spcAft>
+              <a:buSzPct val="100000"/>
+              <a:buChar char="•"/>
+            </a:pPr>
+            <a:r>
+              <a:rPr lang="en-US" sz="1350" dirty="0">
+                <a:solidFill>
+                  <a:srgbClr val="1D2B2A"/>
+                </a:solidFill>
+                <a:latin typeface="Calibri" pitchFamily="34" charset="0"/>
+                <a:ea typeface="Calibri" pitchFamily="34" charset="-122"/>
+                <a:cs typeface="Calibri" pitchFamily="34" charset="-120"/>
+              </a:rPr>
+              <a:t>Bank fees used up customers' savings withdrawals</a:t>
+            </a:r>
+            <a:endParaRPr lang="en-US" sz="1350" dirty="0"/>
+          </a:p>
+          <a:p>
+            <a:pPr marL="342900" indent="-342900">
+              <a:spcAft>
+                <a:spcPts val="600"/>
+              </a:spcAft>
+              <a:buSzPct val="100000"/>
+              <a:buChar char="•"/>
+            </a:pPr>
+            <a:r>
+              <a:rPr lang="en-US" sz="1350" dirty="0">
+                <a:solidFill>
+                  <a:srgbClr val="1D2B2A"/>
+                </a:solidFill>
+                <a:latin typeface="Calibri" pitchFamily="34" charset="0"/>
+                <a:ea typeface="Calibri" pitchFamily="34" charset="-122"/>
+                <a:cs typeface="Calibri" pitchFamily="34" charset="-120"/>
+              </a:rPr>
+              <a:t>Account closure ignored holds and pending payments</a:t>
+            </a:r>
+            <a:endParaRPr lang="en-US" sz="1350" dirty="0"/>
+          </a:p>
+          <a:p>
+            <a:pPr marL="342900" indent="-342900">
+              <a:spcAft>
+                <a:spcPts val="600"/>
+              </a:spcAft>
+              <a:buSzPct val="100000"/>
+              <a:buChar char="•"/>
+            </a:pPr>
+            <a:r>
+              <a:rPr lang="en-US" sz="1350" dirty="0">
+                <a:solidFill>
+                  <a:srgbClr val="1D2B2A"/>
+                </a:solidFill>
+                <a:latin typeface="Calibri" pitchFamily="34" charset="0"/>
+                <a:ea typeface="Calibri" pitchFamily="34" charset="-122"/>
+                <a:cs typeface="Calibri" pitchFamily="34" charset="-120"/>
+              </a:rPr>
+              <a:t>No delegated limit on credit approvals</a:t>
+            </a:r>
+            <a:endParaRPr lang="en-US" sz="1350" dirty="0"/>
+          </a:p>
+        </p:txBody>
+      </p:sp>
+    </p:spTree>
+  </p:cSld>
+  <p:clrMapOvr>
+    <a:masterClrMapping/>
+  </p:clrMapOvr>
+</p:sld>
+</file>
+
+<file path=ppt/slides/slide14.xml><?xml version="1.0" encoding="utf-8"?>
+<p:sld xmlns:a="http://schemas.openxmlformats.org/drawingml/2006/main" xmlns:r="http://schemas.openxmlformats.org/officeDocument/2006/relationships" xmlns:p="http://schemas.openxmlformats.org/presentationml/2006/main">
+  <p:cSld name="Slide 14">
     <p:bg>
       <p:bgPr>
         <a:solidFill>

</xml_diff>

<commit_message>
Add the authors: Khizar Rizwan and Bilal Nadeem
Names added to the report cover, the title slide, the README, both
Python file headers and the GUI sign-in screen; report PDF/DOCX, deck
and the sign-in screenshot rebuilt.

Co-Authored-By: Claude Opus 5.5 <noreply@anthropic.com>
Claude-Session: https://claude.ai/code/session_01SahYJB3mwF36eBHRbWfj6o
</commit_message>
<xml_diff>
--- a/docs/Viva_Presentation.pptx
+++ b/docs/Viva_Presentation.pptx
@@ -2360,7 +2360,7 @@
                 <a:ea typeface="Calibri" pitchFamily="34" charset="-122"/>
                 <a:cs typeface="Calibri" pitchFamily="34" charset="-120"/>
               </a:rPr>
-              <a:t>Name: ____________________</a:t>
+              <a:t>Prepared by: Khizar Rizwan and Bilal Nadeem</a:t>
             </a:r>
             <a:endParaRPr lang="en-US" sz="1300" dirty="0"/>
           </a:p>
@@ -2377,7 +2377,7 @@
                 <a:ea typeface="Calibri" pitchFamily="34" charset="-122"/>
                 <a:cs typeface="Calibri" pitchFamily="34" charset="-120"/>
               </a:rPr>
-              <a:t>Roll number: _____________</a:t>
+              <a:t>Roll numbers: _____________</a:t>
             </a:r>
             <a:endParaRPr lang="en-US" sz="1300" dirty="0"/>
           </a:p>

</xml_diff>

<commit_message>
Add Project Presentation 1 deck and speech; Bilal Nadeem is the instructor
- docs/Progress_Presentation_1.pptx: 8-slide, 5-minute progress
  checkpoint (progress timeline, research findings, class diagram, UML
  inheritance, flowchart, state machine, next steps); notes are the speech
- docs/Progress_Presentation_1_Speech.md/.docx: timed script, how each
  marking criterion is met, likely questions, rehearsal checklist
- tools/make_progress_deck.js builds the deck
- Course outline shows Bilal Nadeem is the course instructor: author
  lines now read "Khizar Rizwan", with the course and instructor named;
  report, viva deck and sign-in screenshot rebuilt

Co-Authored-By: Claude Opus 5.5 <noreply@anthropic.com>
Claude-Session: https://claude.ai/code/session_01SahYJB3mwF36eBHRbWfj6o
</commit_message>
<xml_diff>
--- a/docs/Viva_Presentation.pptx
+++ b/docs/Viva_Presentation.pptx
@@ -2360,7 +2360,7 @@
                 <a:ea typeface="Calibri" pitchFamily="34" charset="-122"/>
                 <a:cs typeface="Calibri" pitchFamily="34" charset="-120"/>
               </a:rPr>
-              <a:t>Prepared by: Khizar Rizwan and Bilal Nadeem</a:t>
+              <a:t>Prepared by: Khizar Rizwan</a:t>
             </a:r>
             <a:endParaRPr lang="en-US" sz="1300" dirty="0"/>
           </a:p>
@@ -2377,7 +2377,7 @@
                 <a:ea typeface="Calibri" pitchFamily="34" charset="-122"/>
                 <a:cs typeface="Calibri" pitchFamily="34" charset="-120"/>
               </a:rPr>
-              <a:t>Roll numbers: _____________</a:t>
+              <a:t>Roll number: _____________</a:t>
             </a:r>
             <a:endParaRPr lang="en-US" sz="1300" dirty="0"/>
           </a:p>
@@ -2394,7 +2394,7 @@
                 <a:ea typeface="Calibri" pitchFamily="34" charset="-122"/>
                 <a:cs typeface="Calibri" pitchFamily="34" charset="-120"/>
               </a:rPr>
-              <a:t>Course: __________________</a:t>
+              <a:t>CS2012 Introduction to OOP - Instructor: Bilal Nadeem</a:t>
             </a:r>
             <a:endParaRPr lang="en-US" sz="1300" dirty="0"/>
           </a:p>

</xml_diff>